<commit_message>
Lecture 8: expand transformer (PE heatmap, RoPE, cross-attention, 3 families); rewrite Quiz 8 to context=K/V; introduce Casanovo on first use
</commit_message>
<xml_diff>
--- a/slides/pptx/lecture08_transformer.pptx
+++ b/slides/pptx/lecture08_transformer.pptx
@@ -24,6 +24,9 @@
     <p:sldId id="272" r:id="rId24"/>
     <p:sldId id="273" r:id="rId25"/>
     <p:sldId id="274" r:id="rId26"/>
+    <p:sldId id="275" r:id="rId27"/>
+    <p:sldId id="276" r:id="rId28"/>
+    <p:sldId id="277" r:id="rId29"/>
   </p:sldIdLst>
   <p:sldSz cx="12191695" cy="6858000" type="screen4x3"/>
   <p:notesSz cx="6858000" cy="9144000"/>
@@ -520,7 +523,7 @@
           <a:lstStyle/>
           <a:p>
             <a:r>
-              <a:t>Monday morning, hour two, straight on from Lecture 7. Last hour we built one thing — self-attention, a soft lookup that is just a weighted average. This hour we bolt on the four missing pieces and the whole transformer falls out, then we turn it loose on spectra and show how to borrow a pretrained one for a lab with only a few hundred labels. Nothing new that is hard: the only arithmetic is a mean and a subtract-and-divide (layer norm), both by hand. Same interactive spine as every lecture so far: each worked example (I-do) is followed by one you do yourself (you-do), and every quiz-backed you-do IS a Quiz 8 item. Hand out Quiz 8 now, blank; the room fills it across the hour. Quiz 8 has four items and we hit all four live — label the four transformer blocks (Q1), match data to tokenization strategy (Q2), the fine-tune-vs-scratch call (Q3), and which-norm-averages-what (Q4). Keep the Quiz 7 sheet handy — attention is the beating heart of what we assemble today.</a:t>
+              <a:t>Monday morning, hour two, straight on from Lecture 7. Last hour we built one thing — self-attention, a soft lookup that is just a weighted average. This hour we bolt on the four missing pieces and the whole transformer falls out, then we turn it loose on spectra and show how to borrow a pretrained one for a lab with only a few hundred labels. Nothing new that is hard: the only arithmetic is a mean and a subtract-and-divide (layer norm), both by hand. Same interactive spine as every lecture so far: each worked example (I-do) is followed by one you do yourself (you-do), and every quiz-backed you-do IS a Quiz 8 item. Hand out Quiz 8 now, blank; the room fills it across the hour. Quiz 8 has four items and we hit all four live — context is the values (Q1), the encoder's K,V is the cross-attention context (Q2), match data to a tokenization strategy (Q3), and the fine-tune-vs-scratch call (Q4). Keep the Quiz 7 sheet handy — attention is the beating heart of what we assemble today.</a:t>
             </a:r>
           </a:p>
           <a:p/>
@@ -591,7 +594,7 @@
           <a:lstStyle/>
           <a:p>
             <a:r>
-              <a:t>Pivot to the question this room actually cares about. Everything so far assumed the input is already a sequence of token vectors — trivial for a peptide (one token per residue, Lecture 7). But a raw spectrum is 6,000 intensities, an imaging-MS slide is a picture, a peak list is a ragged set of (m/z, intensity) pairs. None of those is "a sentence." So the design choice that matters for applying transformers to MS is TOKENIZATION: how to turn your signal into the sequence of vectors the transformer expects. Three strategies, all in real published use, coming up — then a decision chart the room uses on the quiz.</a:t>
+              <a:t>Two dominant wirings, both built from the same block. Encoder-only models (BERT is the famous one) keep just the left stack: they read the entire input at once, every token attending both left and right, and produce either one label for the whole sequence (classification) or a rich per-token embedding — the natural fit for "is this spectrum resistant or susceptible?" or "embed this peptide for search." Decoder-only models (the GPT family) keep the right stack with masked attention: they generate one token at a time, each new token attending only to what came before — the natural fit for GENERATION, like writing a peptide sequence residue by residue. The old encoder→decoder pairing (translation: read all of language A, write language B) is exactly Casanovo's shape: read a spectrum, write a peptide. Tie it to the room's task list: classification jobs → encoder-only; generation/de-novo jobs → decoder-only or encoder–decoder. Lab 3 fine-tunes an encoder-only model (DistilBERT) for classification.</a:t>
             </a:r>
           </a:p>
           <a:p/>
@@ -662,7 +665,7 @@
           <a:lstStyle/>
           <a:p>
             <a:r>
-              <a:t>The three tokenization strategies side by side on the identical spectrum, so the contrast is about the METHOD, not the data. (a) Patch + linear projection: chop the signal into fixed-width chunks and multiply each chunk by a learned matrix to get one token vector — this is exactly how a Vision Transformer (ViT) turns an image into tokens, and it works on a binned spectrum or a 2D imaging-MS tile. (b) CNN front-end: run a small 1D convolutional stack (their Lab-2 machinery) over the signal and treat its output positions as token embeddings — the conv does the local peak-shape detection, the transformer does the long-range mixing. (c) Peak-as-token: throw away the empty baseline and keep only the peaks; each peak becomes a token whose vector encodes its m/z and intensity — this is how Casanovo reads a spectrum, and it is efficient because a spectrum is mostly zeros. No single winner — which one fits depends on the data, which is the very next slide.</a:t>
+              <a:t>This is the wire the two-stack diagram hides, and it carries the two Quiz 8 context items (Q1, Q2). An encoder-decoder works in two phases. First the ENCODER reads the whole input once (self-attention over all peaks) and produces a set of key/value vectors — the model's MEMORY of the spectrum. Then the DECODER writes the output one token at a time, and at every step does two attentions: ① masked self-attention over the residues already written (so it can't peek ahead), and ② CROSS-attention, where the query comes from the decoder's current position but the keys and values come from the ENCODER's memory. That second attention is how the output stays grounded in the input. Casanovo: each amino acid it writes cross-attends back to the actual fragment peaks, so the peptide it produces explains THIS spectrum. Quiz 8 answers: Q1 — of query/key/value, the VALUE carries the content that lands in the output (context = a blend of values; keys and query only set the weights). Q2 — the encoder's K,V is computed ONCE and held fixed for the whole decode (the memory/context of the spectrum); swap in a different spectrum's K,V halfway through and the rest of the peptide is sequenced against the wrong spectrum → a wrong/incoherent peptide, because the K,V IS the context the output is grounded in. That is also why, without cross-attention at all, the decoder would hallucinate a generic peptide unrelated to the data. Harvest one answer for each, then the room fills Q1–Q2.</a:t>
             </a:r>
           </a:p>
           <a:p/>
@@ -733,7 +736,7 @@
           <a:lstStyle/>
           <a:p>
             <a:r>
-              <a:t>The decision chart makes the choice explicit and testable (rule 3: Q2 must be derivable from this chart). Match the strategy to the SHAPE of the data. If the signal is genuinely 2D — an imaging-MS image or an LC×MS heatmap — cut it into patches and project, the ViT recipe. If it is a dense, evenly-sampled 1D signal — a binned full-scan spectrum or a chromatogram — a small CNN front-end is the natural condenser: it exploits local structure before the transformer mixes globally. If it is already a sparse list of peaks with variable count — the (m/z, intensity) pairs a spectral library uses — treat each peak as a token, the most efficient path and the one Casanovo takes. These three rules are exactly the three matches on Quiz 8 Q2. Next slide the room does the matching.</a:t>
+              <a:t>Zoom out: the same block wires into three families, and choosing the right one is a real design decision this room will make. Encoder-only (BERT, DistilBERT, ESM-2): read the whole input both directions, emit one label or embedding — classification/search. Encoder–decoder (the original Transformer, T5, Flan-T5, and Casanovo): an encoder reads the input, a decoder writes a DIFFERENT sequence, joined by the cross-attention we just drew — translation, summarization, de novo sequencing. Decoder-only (GPT, LLaMA): a single causal stack that continues text one token at a time — chat and free-text generation, "everything as next-token prediction." Decide beat (60 sec, then reveal): (a) resistant/susceptible call → ENCODER-ONLY (one label from the whole input, exactly Lab 3's DistilBERT); (b) spectrum → peptide sequence → ENCODER–DECODER (read spectrum, write a new sequence — Casanovo); (c) draft a free-text QC report → DECODER-ONLY (generate prose — GPT/LLaMA). This task→family mapping is a strong candidate for a new Quiz 8 item; for now it runs as a live decide beat.</a:t>
             </a:r>
           </a:p>
           <a:p/>
@@ -804,7 +807,7 @@
           <a:lstStyle/>
           <a:p>
             <a:r>
-              <a:t>YOU-DO = Quiz 8 Q2 (the same three rules, now applied; it assesses the "name/pick a tokenization strategy" outcome). Answers, straight off the decision chart: imaging-MS image (2D) → patches + linear projection (ViT); raw binned spectrum (dense 1D) → CNN front-end → token embeddings; peak list (sparse (m/z, intensity)) → peak-as-token (Casanovo). Each strategy used once. Identical to the Quiz 8 Q2 key. Take one match from the floor, then have them fill Q2. If someone matches the binned spectrum to patches, accept the reasoning but point to the chart's primary rule — a dense, ordered 1D signal is where a CNN front-end shines.</a:t>
+              <a:t>Pivot to the question this room actually cares about. Everything so far assumed the input is already a sequence of token vectors — trivial for a peptide (one token per residue, Lecture 7). But a raw spectrum is 6,000 intensities, an imaging-MS slide is a picture, a peak list is a ragged set of (m/z, intensity) pairs. None of those is "a sentence." So the design choice that matters for applying transformers to MS is TOKENIZATION: how to turn your signal into the sequence of vectors the transformer expects. Three strategies, all in real published use, coming up — then a decision chart the room uses on the quiz.</a:t>
             </a:r>
           </a:p>
           <a:p/>
@@ -875,7 +878,7 @@
           <a:lstStyle/>
           <a:p>
             <a:r>
-              <a:t>Casanovo (Yilmaz et al., 2022) makes the whole hour concrete: it treats de novo peptide sequencing as machine translation — spectrum language in, peptide language out. The encoder tokenizes each fragment peak as a token (strategy c) and reads them all with self-attention; the decoder generates the amino-acid sequence one residue at a time, cross-attending back to the peaks, stopping at the end of the peptide — the encoder→decoder wiring from two slides ago. The point for this room: the transformer they just assembled is already doing real mass-spec work, and the tokenization choice (peak-as- token) is the same decision they just made on the quiz. Lab 3's bonus cell fine-tunes a protein language model (ESM-2) on peptides — same alphabet family. Keep this fast, ~90 seconds; it is a payoff, not new mechanics. Beat answer: an encoder-only model can only emit ONE fixed output (a label or embedding); de novo sequencing must PRODUCE a variable-length peptide one residue at a time, which is exactly what an autoregressive decoder does — so you need the decoder to generate, the encoder to read the spectrum.</a:t>
+              <a:t>The three tokenization strategies side by side on the identical spectrum, so the contrast is about the METHOD, not the data. (a) Patch + linear projection: chop the signal into fixed-width chunks and multiply each chunk by a learned matrix to get one token vector — this is exactly how a Vision Transformer (ViT) turns an image into tokens, and it works on a binned spectrum or a 2D imaging-MS tile. (b) CNN front-end: run a small 1D convolutional stack (their Lab-2 machinery) over the signal and treat its output positions as token embeddings — the conv does the local peak-shape detection, the transformer does the long-range mixing. (c) Peak-as-token: throw away the empty baseline and keep only the peaks; each peak becomes a token whose vector encodes its m/z and intensity — this is how Casanovo reads a spectrum, and it is efficient because a spectrum is mostly zeros. No single winner — which one fits depends on the data, which is the very next slide.</a:t>
             </a:r>
           </a:p>
           <a:p/>
@@ -946,7 +949,7 @@
           <a:lstStyle/>
           <a:p>
             <a:r>
-              <a:t>The single most useful idea for a small lab. A transformer has millions of weights; training them from scratch needs a mountain of labeled data most labs will never have. Transfer learning sidesteps that: take a model someone already pretrained on a huge unlabeled or loosely-labeled corpus — its BODY has learned general-purpose features (peak shapes, sequence motifs, context) — and reuse it. Two moves: FREEZE the body so its learned weights stay put, and attach a small NEW head (a fresh output layer) sized to YOUR task, say a two-class susceptible/resistant readout. You then train only the head on your few hundred labels — cheap, fast, hard to overfit because there are few new weights. "Fine-tuning" is the umbrella term for adapting the pretrained model: head-only training is the most conservative; you can also unfreeze a little of the top of the body and train it gently (a much smaller learning rate — why? you're nudging good weights, not discovering them, the Lab-3 blank). Next slide, why this rescues a 500–800-spectrum project; then the room makes the call.</a:t>
+              <a:t>The decision chart makes the choice explicit and testable (rule 3: Q2 must be derivable from this chart). Match the strategy to the SHAPE of the data. If the signal is genuinely 2D — an imaging-MS image or an LC×MS heatmap — cut it into patches and project, the ViT recipe. If it is a dense, evenly-sampled 1D signal — a binned full-scan spectrum or a chromatogram — a small CNN front-end is the natural condenser: it exploits local structure before the transformer mixes globally. If it is already a sparse list of peaks with variable count — the (m/z, intensity) pairs a spectral library uses — treat each peak as a token, the most efficient path and the one Casanovo takes. These three rules are exactly the three matches on Quiz 8 Q3. Next slide the room does the matching.</a:t>
             </a:r>
           </a:p>
           <a:p/>
@@ -1017,7 +1020,7 @@
           <a:lstStyle/>
           <a:p>
             <a:r>
-              <a:t>Land why the freeze-and-fine-tune move is not just convenient but decisive for this audience. Training from scratch on a few hundred spectra is a textbook overfitting/underfitting trap (Lecture 4): millions of free weights, almost no signal to pin them down, so the model memorizes noise or collapses to predicting the majority class — near chance on anything imbalanced. Fine- tuning inverts the arithmetic: the pretrained body supplies the general features for free, so the only weights you fit are the small head, and a few hundred labels are plenty to fit a small head well. Use a smaller learning rate than from-scratch training, because you're making tiny corrections to already-good weights. This is not hand-waving: Lab 3 runs the exact three-way comparison — full fine-tune vs. frozen-body-head-only vs. from-scratch — and from-scratch lands near the majority floor while the fine-tuned model reaches far higher, on the same small dataset in the same session. Next slide the room makes the call themselves (Quiz 8 Q3).</a:t>
+              <a:t>YOU-DO = Quiz 8 Q3 (the same three rules, now applied; it assesses the "name/pick a tokenization strategy" outcome). Answers, straight off the decision chart: imaging-MS image (2D) → patches + linear projection (ViT); raw binned spectrum (dense 1D) → CNN front-end → token embeddings; peak list (sparse (m/z, intensity)) → peak-as-token (Casanovo). Each strategy used once. Identical to the Quiz 8 Q3 key. Take one match from the floor, then have them fill Q2. If someone matches the binned spectrum to patches, accept the reasoning but point to the chart's primary rule — a dense, ordered 1D signal is where a CNN front-end shines.</a:t>
             </a:r>
           </a:p>
           <a:p/>
@@ -1088,7 +1091,7 @@
           <a:lstStyle/>
           <a:p>
             <a:r>
-              <a:t>YOU-DO = Quiz 8 Q3 (the fine-tune-vs-scratch scenario; it assesses the transfer-learning outcome). Expected answer: FINE-TUNE — freeze the pretrained body and train a small new head on the 800 labels (optionally unfreeze a little of the top with a small learning rate). Reason (any one is full credit): 800 labels are far too few to train millions of weights from scratch without overfitting/landing at the majority-class floor; the pretrained body already learned general spectral features from the 2 million spectra, so you only need to fit a small head, which 800 labels can do well. This is a 💬 pair beat — 90 seconds, harvest one or two answers with their reason — then everyone fills Q3. That's all four Quiz 8 items worked live.</a:t>
+              <a:t>Casanovo (Yilmaz et al., 2022) makes the whole hour concrete: it treats de novo peptide sequencing as machine translation — spectrum language in, peptide language out. The encoder tokenizes each fragment peak as a token (strategy c) and reads them all with self-attention; the decoder generates the amino-acid sequence one residue at a time, cross-attending back to the peaks, stopping at the end of the peptide — the encoder→decoder wiring from two slides ago. The point for this room: the transformer they just assembled is already doing real mass-spec work, and the tokenization choice (peak-as- token) is the same decision they just made on the quiz. Lab 3's bonus cell fine-tunes a protein language model (ESM-2) on peptides — same alphabet family. Keep this fast, ~90 seconds; it is a payoff, not new mechanics. Beat answer: an encoder-only model can only emit ONE fixed output (a label or embedding); de novo sequencing must PRODUCE a variable-length peptide one residue at a time, which is exactly what an autoregressive decoder does — so you need the decoder to generate, the encoder to read the spectrum.</a:t>
             </a:r>
           </a:p>
           <a:p/>
@@ -1159,7 +1162,7 @@
           <a:lstStyle/>
           <a:p>
             <a:r>
-              <a:t>Recap = the Lecture 8 outcomes, each already a you-do this hour tied to a Quiz 8 item: Q1 the four-block label, Q2 the tokenization matches, Q3 the fine-tune-vs-scratch call, Q4 which-norm-averages-what. The encoder-vs-decoder (BERT vs. GPT) distinction is taught this hour but is not a separate quiz item — so it rides alongside the Q1 block-labeling bullet without its own tag. Note the sheet was done out of numeric order (Q4 first, at the norm slide) — that's fine, it's a distributed worksheet, not a test block. There is no separate quiz block; they've done all four across the hour. Have them keep the sheet as the on-ramp to Lab 3, then the closing bridge.</a:t>
+              <a:t>The single most useful idea for a small lab. A transformer has millions of weights; training them from scratch needs a mountain of labeled data most labs will never have. Transfer learning sidesteps that: take a model someone already pretrained on a huge unlabeled or loosely-labeled corpus — its BODY has learned general-purpose features (peak shapes, sequence motifs, context) — and reuse it. Two moves: FREEZE the body so its learned weights stay put, and attach a small NEW head (a fresh output layer) sized to YOUR task, say a two-class susceptible/resistant readout. You then train only the head on your few hundred labels — cheap, fast, hard to overfit because there are few new weights. "Fine-tuning" is the umbrella term for adapting the pretrained model: head-only training is the most conservative; you can also unfreeze a little of the top of the body and train it gently (a much smaller learning rate — why? you're nudging good weights, not discovering them, the Lab-3 blank). Next slide, why this rescues a 500–800-spectrum project; then the room makes the call.</a:t>
             </a:r>
           </a:p>
           <a:p/>
@@ -1230,7 +1233,7 @@
           <a:lstStyle/>
           <a:p>
             <a:r>
-              <a:t>Hand the final minutes to finishing Quiz 8 and selling Lab 3. Lab 3 is the transfer-learning slide made real: load a pretrained transformer, replace its head, freeze the body, fine-tune on a small dataset, and race it against training from scratch — the from-scratch model lands near the majority floor while the fine-tuned one reaches far higher, the game-changer lesson made visible. The bonus cell reruns the identical recipe on ESM-2 over peptides — "DistilBERT read billions of English words; ESM-2 read hundreds of millions of protein sequences; same move, different alphabet." Then Colab is up and we mark Quiz 8 together as Lab 3 begins.</a:t>
+              <a:t>Land why the freeze-and-fine-tune move is not just convenient but decisive for this audience. Training from scratch on a few hundred spectra is a textbook overfitting/underfitting trap (Lecture 4): millions of free weights, almost no signal to pin them down, so the model memorizes noise or collapses to predicting the majority class — near chance on anything imbalanced. Fine- tuning inverts the arithmetic: the pretrained body supplies the general features for free, so the only weights you fit are the small head, and a few hundred labels are plenty to fit a small head well. Use a smaller learning rate than from-scratch training, because you're making tiny corrections to already-good weights. This is not hand-waving: Lab 3 runs the exact three-way comparison — full fine-tune vs. frozen-body-head-only vs. from-scratch — and from-scratch lands near the majority floor while the fine-tuned model reaches far higher, on the same small dataset in the same session. Next slide the room makes the call themselves (Quiz 8 Q4).</a:t>
             </a:r>
           </a:p>
           <a:p/>
@@ -1327,6 +1330,219 @@
 </p:notes>
 </file>
 
+<file path=ppt/notesSlides/notesSlide20.xml><?xml version="1.0" encoding="utf-8"?>
+<p:notes xmlns:a="http://schemas.openxmlformats.org/drawingml/2006/main" xmlns:p="http://schemas.openxmlformats.org/presentationml/2006/main" xmlns:r="http://schemas.openxmlformats.org/officeDocument/2006/relationships">
+  <p:cSld>
+    <p:spTree>
+      <p:nvGrpSpPr>
+        <p:cNvPr id="1" name=""/>
+        <p:cNvGrpSpPr/>
+        <p:nvPr/>
+      </p:nvGrpSpPr>
+      <p:grpSpPr>
+        <a:xfrm>
+          <a:off x="0" y="0"/>
+          <a:ext cx="0" cy="0"/>
+          <a:chOff x="0" y="0"/>
+          <a:chExt cx="0" cy="0"/>
+        </a:xfrm>
+      </p:grpSpPr>
+      <p:sp>
+        <p:nvSpPr>
+          <p:cNvPr id="2" name="Slide Image Placeholder 1"/>
+          <p:cNvSpPr>
+            <a:spLocks noGrp="1"/>
+          </p:cNvSpPr>
+          <p:nvPr>
+            <p:ph type="sldImg" idx="2"/>
+          </p:nvPr>
+        </p:nvSpPr>
+        <p:spPr/>
+      </p:sp>
+      <p:sp>
+        <p:nvSpPr>
+          <p:cNvPr id="3" name="Notes Placeholder 2"/>
+          <p:cNvSpPr>
+            <a:spLocks noGrp="1"/>
+          </p:cNvSpPr>
+          <p:nvPr>
+            <p:ph type="body" idx="3" sz="quarter"/>
+          </p:nvPr>
+        </p:nvSpPr>
+        <p:spPr/>
+        <p:txBody>
+          <a:bodyPr/>
+          <a:lstStyle/>
+          <a:p>
+            <a:r>
+              <a:t>YOU-DO = Quiz 8 Q4 (the fine-tune-vs-scratch scenario; it assesses the transfer-learning outcome). Expected answer: FINE-TUNE — freeze the pretrained body and train a small new head on the 800 labels (optionally unfreeze a little of the top with a small learning rate). Reason (any one is full credit): 800 labels are far too few to train millions of weights from scratch without overfitting/landing at the majority-class floor; the pretrained body already learned general spectral features from the 2 million spectra, so you only need to fit a small head, which 800 labels can do well. This is a 💬 pair beat — 90 seconds, harvest one or two answers with their reason — then everyone fills Q4. That's all four Quiz 8 items worked live.</a:t>
+            </a:r>
+          </a:p>
+          <a:p/>
+        </p:txBody>
+      </p:sp>
+      <p:sp>
+        <p:nvSpPr>
+          <p:cNvPr id="4" name="Slide Number Placeholder 3"/>
+          <p:cNvSpPr>
+            <a:spLocks noGrp="1"/>
+          </p:cNvSpPr>
+          <p:nvPr>
+            <p:ph type="sldNum" idx="5" sz="quarter"/>
+          </p:nvPr>
+        </p:nvSpPr>
+        <p:spPr/>
+      </p:sp>
+    </p:spTree>
+  </p:cSld>
+  <p:clrMapOvr>
+    <a:masterClrMapping/>
+  </p:clrMapOvr>
+</p:notes>
+</file>
+
+<file path=ppt/notesSlides/notesSlide21.xml><?xml version="1.0" encoding="utf-8"?>
+<p:notes xmlns:a="http://schemas.openxmlformats.org/drawingml/2006/main" xmlns:p="http://schemas.openxmlformats.org/presentationml/2006/main" xmlns:r="http://schemas.openxmlformats.org/officeDocument/2006/relationships">
+  <p:cSld>
+    <p:spTree>
+      <p:nvGrpSpPr>
+        <p:cNvPr id="1" name=""/>
+        <p:cNvGrpSpPr/>
+        <p:nvPr/>
+      </p:nvGrpSpPr>
+      <p:grpSpPr>
+        <a:xfrm>
+          <a:off x="0" y="0"/>
+          <a:ext cx="0" cy="0"/>
+          <a:chOff x="0" y="0"/>
+          <a:chExt cx="0" cy="0"/>
+        </a:xfrm>
+      </p:grpSpPr>
+      <p:sp>
+        <p:nvSpPr>
+          <p:cNvPr id="2" name="Slide Image Placeholder 1"/>
+          <p:cNvSpPr>
+            <a:spLocks noGrp="1"/>
+          </p:cNvSpPr>
+          <p:nvPr>
+            <p:ph type="sldImg" idx="2"/>
+          </p:nvPr>
+        </p:nvSpPr>
+        <p:spPr/>
+      </p:sp>
+      <p:sp>
+        <p:nvSpPr>
+          <p:cNvPr id="3" name="Notes Placeholder 2"/>
+          <p:cNvSpPr>
+            <a:spLocks noGrp="1"/>
+          </p:cNvSpPr>
+          <p:nvPr>
+            <p:ph type="body" idx="3" sz="quarter"/>
+          </p:nvPr>
+        </p:nvSpPr>
+        <p:spPr/>
+        <p:txBody>
+          <a:bodyPr/>
+          <a:lstStyle/>
+          <a:p>
+            <a:r>
+              <a:t>Recap = the Lecture 8 outcomes, each already a you-do this hour tied to a Quiz 8 item: Q1 context = a blend of values, Q2 the encoder's K,V as the cross-attention context (both on the cross-attention slide), Q3 the tokenization matches, Q4 the fine-tune-vs-scratch call. Positional encoding (sinusoidal + RoPE), layer norm, and the three architecture families are taught with live do-it-together / pair / decide beats but are not separate quiz items this hour. There is no end-of-class quiz block; they've done all four across the hour. Have them keep the sheet as the on-ramp to Lab 3, then the closing bridge.</a:t>
+            </a:r>
+          </a:p>
+          <a:p/>
+        </p:txBody>
+      </p:sp>
+      <p:sp>
+        <p:nvSpPr>
+          <p:cNvPr id="4" name="Slide Number Placeholder 3"/>
+          <p:cNvSpPr>
+            <a:spLocks noGrp="1"/>
+          </p:cNvSpPr>
+          <p:nvPr>
+            <p:ph type="sldNum" idx="5" sz="quarter"/>
+          </p:nvPr>
+        </p:nvSpPr>
+        <p:spPr/>
+      </p:sp>
+    </p:spTree>
+  </p:cSld>
+  <p:clrMapOvr>
+    <a:masterClrMapping/>
+  </p:clrMapOvr>
+</p:notes>
+</file>
+
+<file path=ppt/notesSlides/notesSlide22.xml><?xml version="1.0" encoding="utf-8"?>
+<p:notes xmlns:a="http://schemas.openxmlformats.org/drawingml/2006/main" xmlns:p="http://schemas.openxmlformats.org/presentationml/2006/main" xmlns:r="http://schemas.openxmlformats.org/officeDocument/2006/relationships">
+  <p:cSld>
+    <p:spTree>
+      <p:nvGrpSpPr>
+        <p:cNvPr id="1" name=""/>
+        <p:cNvGrpSpPr/>
+        <p:nvPr/>
+      </p:nvGrpSpPr>
+      <p:grpSpPr>
+        <a:xfrm>
+          <a:off x="0" y="0"/>
+          <a:ext cx="0" cy="0"/>
+          <a:chOff x="0" y="0"/>
+          <a:chExt cx="0" cy="0"/>
+        </a:xfrm>
+      </p:grpSpPr>
+      <p:sp>
+        <p:nvSpPr>
+          <p:cNvPr id="2" name="Slide Image Placeholder 1"/>
+          <p:cNvSpPr>
+            <a:spLocks noGrp="1"/>
+          </p:cNvSpPr>
+          <p:nvPr>
+            <p:ph type="sldImg" idx="2"/>
+          </p:nvPr>
+        </p:nvSpPr>
+        <p:spPr/>
+      </p:sp>
+      <p:sp>
+        <p:nvSpPr>
+          <p:cNvPr id="3" name="Notes Placeholder 2"/>
+          <p:cNvSpPr>
+            <a:spLocks noGrp="1"/>
+          </p:cNvSpPr>
+          <p:nvPr>
+            <p:ph type="body" idx="3" sz="quarter"/>
+          </p:nvPr>
+        </p:nvSpPr>
+        <p:spPr/>
+        <p:txBody>
+          <a:bodyPr/>
+          <a:lstStyle/>
+          <a:p>
+            <a:r>
+              <a:t>Hand the final minutes to finishing Quiz 8 and selling Lab 3. Lab 3 is the transfer-learning slide made real: load a pretrained transformer, replace its head, freeze the body, fine-tune on a small dataset, and race it against training from scratch — the from-scratch model lands near the majority floor while the fine-tuned one reaches far higher, the game-changer lesson made visible. The bonus cell reruns the identical recipe on ESM-2 over peptides — "DistilBERT read billions of English words; ESM-2 read hundreds of millions of protein sequences; same move, different alphabet." Then Colab is up and we mark Quiz 8 together as Lab 3 begins.</a:t>
+            </a:r>
+          </a:p>
+          <a:p/>
+        </p:txBody>
+      </p:sp>
+      <p:sp>
+        <p:nvSpPr>
+          <p:cNvPr id="4" name="Slide Number Placeholder 3"/>
+          <p:cNvSpPr>
+            <a:spLocks noGrp="1"/>
+          </p:cNvSpPr>
+          <p:nvPr>
+            <p:ph type="sldNum" idx="5" sz="quarter"/>
+          </p:nvPr>
+        </p:nvSpPr>
+        <p:spPr/>
+      </p:sp>
+    </p:spTree>
+  </p:cSld>
+  <p:clrMapOvr>
+    <a:masterClrMapping/>
+  </p:clrMapOvr>
+</p:notes>
+</file>
+
 <file path=ppt/notesSlides/notesSlide3.xml><?xml version="1.0" encoding="utf-8"?>
 <p:notes xmlns:a="http://schemas.openxmlformats.org/drawingml/2006/main" xmlns:p="http://schemas.openxmlformats.org/presentationml/2006/main" xmlns:r="http://schemas.openxmlformats.org/officeDocument/2006/relationships">
   <p:cSld>
@@ -1443,7 +1659,7 @@
           <a:lstStyle/>
           <a:p>
             <a:r>
-              <a:t>Normalization keeps activations in a sane range as signals pass through a deep stack — the same drift problem behind Lecture 4's vanishing/exploding gradients — by recentering and rescaling to mean 0, standard size. The only question worth teaching is WHICH AXIS the mean-and-spread is taken over, and the figure answers it with exact numbers. Batch norm (amber column) pools a single feature across every sample in the batch: mean(2,4,0)=2. Layer norm (teal row) pools across one token's own features: mean(2,2,6,6)=4; centre to [−2,−2,2,2]; the population variance is (4+4+4+4)/4=4 so std=2; divide to get [−1,−1,1,1] — all exact, reproducible from the numbers on screen (rule 3). Then the "why layer norm for transformers" beat, stated before the you-do so Q4 is answerable: batch norm's statistics depend on the OTHER samples in the batch, which is fragile when batches are small, mixed-length, or size 1 at inference; layer norm looks only within a single token, so it is independent of batch size and sequence length — perfect for a model whose inputs are ragged sequences. Next slide the room computes both means on a new matrix (Quiz 8 Q4).</a:t>
+              <a:t>Answer "where do the per-position signals come from?" The classic choice (Vaswani 2017) is sine and cosine waves at geometrically-spaced frequencies. LEFT panel: three dimensions drawn as clocks — dim 0 ticks fast, dim 4 is medium, dim 8 barely moves across the whole sequence. RIGHT panel: stack all dimensions into the positional-encoding matrix and read it ROW by row — every position gets its own row, a unique blend of clock readings, so no two positions collide. Two teaching points: (1) neighbouring rows are nearly identical (boxed rows 2–3), so nearby positions get similar codes and attention can judge close-vs-far; (2) the pair beat — you need BOTH fast and slow clocks. Pair answer: with only slow clocks, adjacent positions look the same, so the model can't tell residue 4 from residue 5; fast clocks separate neighbours while slow clocks keep far-apart positions distinct — together every position in a long sequence gets a unique fingerprint. Modern models often LEARN the position vectors instead, but the job is identical. This is the one figure worth lingering on; don't derive the formula.</a:t>
             </a:r>
           </a:p>
           <a:p/>
@@ -1514,7 +1730,7 @@
           <a:lstStyle/>
           <a:p>
             <a:r>
-              <a:t>YOU-DO = Quiz 8 Q4 (same "which axis, then take the mean" skill, new numbers; it assesses the batch-vs-layer outcome). Answers: (a) LAYER norm averages across a token's FEATURES (one row) — mean of tok1 = (2+4+6)/3 = 4. (b) BATCH norm averages down the BATCH (one feature's column across all samples) — mean of f1 = (2+4)/2 = 3. (c) Layer norm needs no batch statistics, so it is stable at batch size 1 and with variable-length sequences, and treats each token independently — which is why transformers use it. Every number is identical to the Quiz 8 Q4 figure and key. Take one axis answer from the floor, then have them fill Q4.</a:t>
+              <a:t>The absolute scheme just shown tags each seat and adds it in. The modern alternative in LLaMA and GPT-NeoX is RoPE (rotary position embedding), and the intuition needs no matrices: rotate each token's QUERY and KEY by an angle proportional to its position (position m → angle mθ). When you then take the attention dot product query·key, the two rotations combine so the score depends only on the DIFFERENCE (m−n) — the gap between the tokens — not their absolute seats. Picture two clock hands: the query at 5θ and the key at 2θ; what the dot product feels is the angle between them, 3θ, the gap. Pair answer: because the model only ever experiences RELATIVE distances, it keeps working on sequences longer than any it trained on — a peptide or chromatogram longer than the training examples still presents in-range gaps, whereas an absolute seat #9000 was never seen. Keep it intuition-only; do NOT derive the rotation. 💬 60-second pair, harvest one answer, then move on.</a:t>
             </a:r>
           </a:p>
           <a:p/>
@@ -1585,7 +1801,7 @@
           <a:lstStyle/>
           <a:p>
             <a:r>
-              <a:t>The reveal: the intimidating "Attention Is All You Need" diagram is entirely blocks this room has already built. Walk the left (encoder) stack bottom to top once: embeddings with positional encoding added (this hour), a Norm (this hour), multi-head self-attention (Lecture 7, the weighted-average lookup), the circled "+" which is the residual skip connection straight from ResNet (Lecture 5's gradient highway), then a feed-forward network — literally the dense MLP from Lab 1 — and another skip. Stack that block N times. The right (decoder) stack is the same parts plus two wrinkles: its self-attention is "masked" (it may only look at tokens already generated, because it writes left to right) and it has a cross-attention block whose queries come from the decoder but whose keys/values come from the ENCODER — that is how the output reads the input. Don't belabour masking; the message is that nothing here is new, it is assembly. This is a real licensed figure (dvgodoy, CC BY 4.0, same series as Lecture 7's multi-head diagram); credit it. Next slide we strip it to the four blocks we will label.</a:t>
+              <a:t>Normalization keeps activations in a sane range as signals pass through a deep stack — the same drift problem behind Lecture 4's vanishing/exploding gradients — by recentering and rescaling to mean 0, standard size. The only question worth teaching is WHICH AXIS the mean-and-spread is taken over, and the figure answers it with exact numbers. Batch norm (amber column) pools a single feature across every sample in the batch: mean(2,4,0)=2. Layer norm (teal row) pools across one token's own features: mean(2,2,6,6)=4; centre to [−2,−2,2,2]; the population variance is (4+4+4+4)/4=4 so std=2; divide to get [−1,−1,1,1] — all exact, reproducible from the numbers on screen (rule 3). Then the "why layer norm for transformers" beat: batch norm's statistics depend on the OTHER samples in the batch, which is fragile when batches are small, mixed-length, or size 1 at inference; layer norm looks only within a single token, so it is independent of batch size and sequence length — perfect for a model whose inputs are ragged sequences. Next slide the room computes both means on a new matrix (a quick do-it-together).</a:t>
             </a:r>
           </a:p>
           <a:p/>
@@ -1656,7 +1872,7 @@
           <a:lstStyle/>
           <a:p>
             <a:r>
-              <a:t>Strip the canonical diagram down to the four blocks the quiz will ask for, each labelled here so the you-do next slide is a fair test (rule 3: Q1 must be labelable from a labelled version taught first). Bottom to top: ① the input — token embeddings with the positional encoding we added two slides ago (label it "Positional encoding", matching the word bank and Quiz 8 Q1 key); ② multi-head self-attention, last hour's query/key/value weighted average run by several heads at once; ③ "Add &amp; Norm" — the residual skip (Lecture 5) adds the block's input back to its output, then layer norm (this hour) rescales; ④ the feed-forward network, a small dense MLP applied to each position — exactly the Lecture-1 neuron stack. Name the residual skip explicitly (the curved arrow) so it isn't mistaken for decoration: it is why deep transformers train at all. One honesty note if a sharp eye catches it: the real dvgodoy diagram on the previous slide places its Norm BEFORE each sub-layer (the modern pre-norm arrangement), whereas this teaching block collapses to a single "Add &amp; Norm" drawn after attention for a clean four-way label — same parts, we've just merged the norms for labeling. Next slide the room labels a blank copy (Quiz 8 Q1).</a:t>
+              <a:t>A quick live compute (do-it-together; not a quiz item this hour). Answers: (a) LAYER norm averages across a token's FEATURES (one row) — mean of tok1 = (2+4+6)/3 = 4. (b) BATCH norm averages down the BATCH (one feature's column across all samples) — mean of f1 = (2+4)/2 = 3. (c) Layer norm needs no batch statistics, so it is stable at batch size 1 and with variable-length sequences, and treats each token independently — which is why transformers use it. Take one axis answer from the floor, work both means live, then move on.</a:t>
             </a:r>
           </a:p>
           <a:p/>
@@ -1727,7 +1943,7 @@
           <a:lstStyle/>
           <a:p>
             <a:r>
-              <a:t>YOU-DO = Quiz 8 Q1 (the same block, labels removed; it assesses the "assemble/label the architecture" outcome). Reading bottom to top, ① = Positional encoding (added to the input embeddings), ② = Multi-head self-attention, ③ = Add &amp; Norm (the residual skip plus layer norm), ④ = Feed-forward network. These are the identical four blocks and order from the labelled I-do slide and from the Quiz 8 Q1 diagram/key. Take one label from the floor, then have them fill Q1. If anyone flips ② and ④, point back to the teaching diagram: attention comes first (mix information across tokens), then the feed-forward refines each token on its own.</a:t>
+              <a:t>The reveal: the intimidating "Attention Is All You Need" diagram is entirely blocks this room has already built. Walk the left (encoder) stack bottom to top once: embeddings with positional encoding added (this hour), a Norm (this hour), multi-head self-attention (Lecture 7, the weighted-average lookup), the circled "+" which is the residual skip connection straight from ResNet (Lecture 5's gradient highway), then a feed-forward network — literally the dense MLP from Lab 1 — and another skip. Stack that block N times. The right (decoder) stack is the same parts plus two wrinkles: its self-attention is "masked" (it may only look at tokens already generated, because it writes left to right) and it has a cross-attention block whose queries come from the decoder but whose keys/values come from the ENCODER — that is how the output reads the input. Don't belabour masking; the message is that nothing here is new, it is assembly. This is a real licensed figure (dvgodoy, CC BY 4.0, same series as Lecture 7's multi-head diagram); credit it. Next slide we strip it to the four blocks it is built from.</a:t>
             </a:r>
           </a:p>
           <a:p/>
@@ -1798,7 +2014,7 @@
           <a:lstStyle/>
           <a:p>
             <a:r>
-              <a:t>Two dominant wirings, both built from the same block. Encoder-only models (BERT is the famous one) keep just the left stack: they read the entire input at once, every token attending both left and right, and produce either one label for the whole sequence (classification) or a rich per-token embedding — the natural fit for "is this spectrum resistant or susceptible?" or "embed this peptide for search." Decoder-only models (the GPT family) keep the right stack with masked attention: they generate one token at a time, each new token attending only to what came before — the natural fit for GENERATION, like writing a peptide sequence residue by residue. The old encoder→decoder pairing (translation: read all of language A, write language B) is exactly Casanovo's shape: read a spectrum, write a peptide. Tie it to the room's task list: classification jobs → encoder-only; generation/de-novo jobs → decoder-only or encoder–decoder. Lab 3 fine-tunes an encoder-only model (DistilBERT) for classification.</a:t>
+              <a:t>Strip the canonical diagram down to the four blocks the quiz will ask for, each labelled here so the room sees the whole machine is just parts it already owns. Bottom to top: ① the input — token embeddings with the positional encoding we added two slides ago (label it "Positional encoding"); ② multi-head self-attention, last hour's query/key/value weighted average run by several heads at once; ③ "Add &amp; Norm" — the residual skip (Lecture 5) adds the block's input back to its output, then layer norm (this hour) rescales; ④ the feed-forward network, a small dense MLP applied to each position — exactly the Lecture-1 neuron stack. Name the residual skip explicitly (the curved arrow) so it isn't mistaken for decoration: it is why deep transformers train at all. One honesty note if a sharp eye catches it: the real dvgodoy diagram on the previous slide places its Norm BEFORE each sub-layer (the modern pre-norm arrangement), whereas this teaching block collapses to a single "Add &amp; Norm" drawn after attention — same parts, the norms merged for a clean picture. The takeaway is assembly, not new material: every block here is something the room already owns. If anyone is unsure why attention comes before the feed-forward: attention mixes information across tokens, then the feed-forward refines each token on its own.</a:t>
             </a:r>
           </a:p>
           <a:p/>
@@ -4891,8 +5107,8 @@
         </p:nvSpPr>
         <p:spPr>
           <a:xfrm>
-            <a:off x="548640" y="1945640"/>
-            <a:ext cx="11064240" cy="2509520"/>
+            <a:off x="548640" y="1778001"/>
+            <a:ext cx="11064240" cy="2844799"/>
           </a:xfrm>
           <a:prstGeom prst="rect">
             <a:avLst/>
@@ -4928,7 +5144,7 @@
                 </a:solidFill>
                 <a:latin typeface="Avenir Next"/>
               </a:rPr>
-              <a:t>Positions · layer norm · the full block · encoder vs decoder · a spectrum → tokens · transfer learning</a:t>
+              <a:t>Positions (sinusoidal + RoPE) · layer norm · the full block · encoder / encoder–decoder / decoder-only + cross-attention · a spectrum → tokens · transfer learning</a:t>
             </a:r>
           </a:p>
         </p:txBody>
@@ -5068,7 +5284,7 @@
                 </a:solidFill>
                 <a:latin typeface="Menlo"/>
               </a:rPr>
-              <a:t>LECTURE 8 · PART FOUR</a:t>
+              <a:t>ASSEMBLE · TWO WAYS TO WIRE IT</a:t>
             </a:r>
           </a:p>
         </p:txBody>
@@ -5081,8 +5297,8 @@
         </p:nvSpPr>
         <p:spPr>
           <a:xfrm>
-            <a:off x="548640" y="2194560"/>
-            <a:ext cx="11064240" cy="2011680"/>
+            <a:off x="548640" y="731520"/>
+            <a:ext cx="11064240" cy="1005840"/>
           </a:xfrm>
           <a:prstGeom prst="rect">
             <a:avLst/>
@@ -5090,58 +5306,68 @@
           <a:noFill/>
         </p:spPr>
         <p:txBody>
-          <a:bodyPr wrap="square" anchor="ctr">
+          <a:bodyPr wrap="square" anchor="t">
             <a:spAutoFit/>
           </a:bodyPr>
           <a:lstStyle/>
           <a:p>
             <a:r>
-              <a:rPr sz="4400" b="1" i="0">
+              <a:rPr sz="3400" b="1" i="0">
                 <a:solidFill>
                   <a:srgbClr val="1B2025"/>
                 </a:solidFill>
                 <a:latin typeface="Avenir Next"/>
               </a:rPr>
-              <a:t>How does a spectrum become tokens?</a:t>
-            </a:r>
-          </a:p>
-          <a:p>
-            <a:pPr>
-              <a:spcBef>
-                <a:spcPts val="1600"/>
-              </a:spcBef>
-            </a:pPr>
-            <a:r>
-              <a:rPr sz="2200" b="0" i="0">
-                <a:solidFill>
-                  <a:srgbClr val="0E7C7B"/>
-                </a:solidFill>
-                <a:latin typeface="Avenir Next"/>
-              </a:rPr>
-              <a:t>a transformer eats a sequence of vectors — so what are the vectors for MS data?</a:t>
-            </a:r>
-          </a:p>
-        </p:txBody>
-      </p:sp>
-      <p:sp>
-        <p:nvSpPr>
-          <p:cNvPr id="5" name="Rectangle 4"/>
+              <a:t>Encoder-only reads; decoder-only writes</a:t>
+            </a:r>
+          </a:p>
+        </p:txBody>
+      </p:sp>
+      <p:pic>
+        <p:nvPicPr>
+          <p:cNvPr id="5" name="Picture 4" descr="fig_bert_vs_gpt.png"/>
+          <p:cNvPicPr>
+            <a:picLocks noChangeAspect="1"/>
+          </p:cNvPicPr>
+          <p:nvPr/>
+        </p:nvPicPr>
+        <p:blipFill>
+          <a:blip r:embed="rId2"/>
+          <a:stretch>
+            <a:fillRect/>
+          </a:stretch>
+        </p:blipFill>
+        <p:spPr>
+          <a:xfrm>
+            <a:off x="1813559" y="1828800"/>
+            <a:ext cx="8534402" cy="3358897"/>
+          </a:xfrm>
+          <a:prstGeom prst="rect">
+            <a:avLst/>
+          </a:prstGeom>
+        </p:spPr>
+      </p:pic>
+      <p:sp>
+        <p:nvSpPr>
+          <p:cNvPr id="6" name="Rectangle 5"/>
           <p:cNvSpPr/>
           <p:nvPr/>
         </p:nvSpPr>
         <p:spPr>
           <a:xfrm>
-            <a:off x="548640" y="2057400"/>
-            <a:ext cx="1280160" cy="54864"/>
+            <a:off x="548640" y="5279137"/>
+            <a:ext cx="10515600" cy="1441703"/>
           </a:xfrm>
           <a:prstGeom prst="rect">
             <a:avLst/>
           </a:prstGeom>
           <a:solidFill>
-            <a:srgbClr val="E09E2F"/>
+            <a:srgbClr val="F1F1EC"/>
           </a:solidFill>
-          <a:ln>
-            <a:noFill/>
+          <a:ln w="12700">
+            <a:solidFill>
+              <a:srgbClr val="E09E2F"/>
+            </a:solidFill>
           </a:ln>
           <a:effectLst/>
         </p:spPr>
@@ -5160,10 +5386,28 @@
           </a:fontRef>
         </p:style>
         <p:txBody>
-          <a:bodyPr rtlCol="0" anchor="ctr"/>
+          <a:bodyPr rtlCol="0" anchor="ctr" wrap="square" lIns="182880" rIns="182880"/>
           <a:lstStyle/>
           <a:p>
             <a:pPr algn="ctr"/>
+            <a:r>
+              <a:rPr sz="1200" b="1" i="0">
+                <a:solidFill>
+                  <a:srgbClr val="E09E2F"/>
+                </a:solidFill>
+                <a:latin typeface="Menlo"/>
+              </a:rPr>
+              <a:t>PAIR · </a:t>
+            </a:r>
+            <a:r>
+              <a:rPr sz="1700" b="0" i="0">
+                <a:solidFill>
+                  <a:srgbClr val="3D444C"/>
+                </a:solidFill>
+                <a:latin typeface="Avenir Next"/>
+              </a:rPr>
+              <a:t>Encoder-only (BERT): read the WHOLE sequence both directions → one label/embedding (call a spectrum resistant/susceptible, or embed a peptide). Decoder-only (GPT): generate the next token left to right → write a peptide residue by residue. 💬 Your turn (30 sec): a model that writes a peptide one residue at a time — encoder-only or decoder-only, and why? Worked answer in the notes.</a:t>
+            </a:r>
           </a:p>
         </p:txBody>
       </p:sp>
@@ -5258,7 +5502,7 @@
                 </a:solidFill>
                 <a:latin typeface="Menlo"/>
               </a:rPr>
-              <a:t>A SPECTRUM → TOKENS · THREE STRATEGIES · I-DO</a:t>
+              <a:t>ENCODER + DECODER · CONTEXT = K,V · I-DO → YOU-DO (Q1–Q2)</a:t>
             </a:r>
           </a:p>
         </p:txBody>
@@ -5272,7 +5516,7 @@
         <p:spPr>
           <a:xfrm>
             <a:off x="548640" y="731520"/>
-            <a:ext cx="11064240" cy="1005840"/>
+            <a:ext cx="11064240" cy="1127760"/>
           </a:xfrm>
           <a:prstGeom prst="rect">
             <a:avLst/>
@@ -5292,14 +5536,14 @@
                 </a:solidFill>
                 <a:latin typeface="Avenir Next"/>
               </a:rPr>
-              <a:t>One spectrum, three ways to tokenize it</a:t>
+              <a:t>Cross-attention: the decoder reads the encoder</a:t>
             </a:r>
           </a:p>
         </p:txBody>
       </p:sp>
       <p:pic>
         <p:nvPicPr>
-          <p:cNvPr id="5" name="Picture 4" descr="fig_tokenization_strategies.png"/>
+          <p:cNvPr id="5" name="Picture 4" descr="fig_cross_attention.png"/>
           <p:cNvPicPr>
             <a:picLocks noChangeAspect="1"/>
           </p:cNvPicPr>
@@ -5313,8 +5557,8 @@
         </p:blipFill>
         <p:spPr>
           <a:xfrm>
-            <a:off x="3258353" y="1828800"/>
-            <a:ext cx="5644813" cy="3358897"/>
+            <a:off x="2831552" y="1828800"/>
+            <a:ext cx="6498415" cy="2840736"/>
           </a:xfrm>
           <a:prstGeom prst="rect">
             <a:avLst/>
@@ -5329,8 +5573,8 @@
         </p:nvSpPr>
         <p:spPr>
           <a:xfrm>
-            <a:off x="548640" y="5279137"/>
-            <a:ext cx="10515600" cy="1441703"/>
+            <a:off x="548640" y="4760976"/>
+            <a:ext cx="10515600" cy="1959864"/>
           </a:xfrm>
           <a:prstGeom prst="rect">
             <a:avLst/>
@@ -5340,7 +5584,7 @@
           </a:solidFill>
           <a:ln w="12700">
             <a:solidFill>
-              <a:srgbClr val="3D444C"/>
+              <a:srgbClr val="E09E2F"/>
             </a:solidFill>
           </a:ln>
           <a:effectLst/>
@@ -5365,13 +5609,22 @@
           <a:p>
             <a:pPr algn="ctr"/>
             <a:r>
+              <a:rPr sz="1200" b="1" i="0">
+                <a:solidFill>
+                  <a:srgbClr val="E09E2F"/>
+                </a:solidFill>
+                <a:latin typeface="Menlo"/>
+              </a:rPr>
+              <a:t>CHECKPOINT · </a:t>
+            </a:r>
+            <a:r>
               <a:rPr sz="1700" b="0" i="0">
                 <a:solidFill>
                   <a:srgbClr val="3D444C"/>
                 </a:solidFill>
                 <a:latin typeface="Avenir Next"/>
               </a:rPr>
-              <a:t>(a) Patch + linear projection — cut the signal into equal chunks, project each to a vector (the ViT idea). (b) CNN front-end — slide a small 1D CNN (Lecture 5) that emits a sequence of token embeddings. (c) Peak-as-token — keep only the peaks; each becomes one token carrying its (m/z, intensity). Same spectrum, three sequences of vectors.</a:t>
+              <a:t>Context = the keys and values. In ANY attention a token's output is a weighted blend of the VALUES — that blend IS its context (query and keys only set the weights). Cross-attention makes it literal: the ENCODER computes its K,V once = the whole spectrum's memory, and every residue the decoder writes queries that SAME context. Your turn → Quiz 8, Q1–Q2: which of Q/K/V carries the content? · is the encoder's K,V fixed or recomputed each step — and what if you swap in a different spectrum's K,V halfway through?</a:t>
             </a:r>
           </a:p>
         </p:txBody>
@@ -5467,7 +5720,7 @@
                 </a:solidFill>
                 <a:latin typeface="Menlo"/>
               </a:rPr>
-              <a:t>A SPECTRUM → TOKENS · WHICH ONE? · I-DO</a:t>
+              <a:t>ENCODER + DECODER · THREE FAMILIES · I-DO → DECIDE</a:t>
             </a:r>
           </a:p>
         </p:txBody>
@@ -5481,7 +5734,7 @@
         <p:spPr>
           <a:xfrm>
             <a:off x="548640" y="731520"/>
-            <a:ext cx="11064240" cy="1005840"/>
+            <a:ext cx="11064240" cy="1127760"/>
           </a:xfrm>
           <a:prstGeom prst="rect">
             <a:avLst/>
@@ -5501,14 +5754,14 @@
                 </a:solidFill>
                 <a:latin typeface="Avenir Next"/>
               </a:rPr>
-              <a:t>Which strategy for which data?</a:t>
+              <a:t>Three families, one block: which one for the job?</a:t>
             </a:r>
           </a:p>
         </p:txBody>
       </p:sp>
       <p:pic>
         <p:nvPicPr>
-          <p:cNvPr id="5" name="Picture 4" descr="fig_tokenization_decision.png"/>
+          <p:cNvPr id="5" name="Picture 4" descr="fig_arch_families.png"/>
           <p:cNvPicPr>
             <a:picLocks noChangeAspect="1"/>
           </p:cNvPicPr>
@@ -5522,8 +5775,8 @@
         </p:blipFill>
         <p:spPr>
           <a:xfrm>
-            <a:off x="1711457" y="1828800"/>
-            <a:ext cx="8738605" cy="3617976"/>
+            <a:off x="2602612" y="1828800"/>
+            <a:ext cx="6956295" cy="3358896"/>
           </a:xfrm>
           <a:prstGeom prst="rect">
             <a:avLst/>
@@ -5538,8 +5791,8 @@
         </p:nvSpPr>
         <p:spPr>
           <a:xfrm>
-            <a:off x="548640" y="5538216"/>
-            <a:ext cx="10515600" cy="1182624"/>
+            <a:off x="548640" y="5279136"/>
+            <a:ext cx="10515600" cy="1441703"/>
           </a:xfrm>
           <a:prstGeom prst="rect">
             <a:avLst/>
@@ -5549,7 +5802,7 @@
           </a:solidFill>
           <a:ln w="12700">
             <a:solidFill>
-              <a:srgbClr val="3D444C"/>
+              <a:srgbClr val="E09E2F"/>
             </a:solidFill>
           </a:ln>
           <a:effectLst/>
@@ -5574,13 +5827,22 @@
           <a:p>
             <a:pPr algn="ctr"/>
             <a:r>
+              <a:rPr sz="1200" b="1" i="0">
+                <a:solidFill>
+                  <a:srgbClr val="E09E2F"/>
+                </a:solidFill>
+                <a:latin typeface="Menlo"/>
+              </a:rPr>
+              <a:t>CHECKPOINT · </a:t>
+            </a:r>
+            <a:r>
               <a:rPr sz="1700" b="0" i="0">
                 <a:solidFill>
                   <a:srgbClr val="3D444C"/>
                 </a:solidFill>
                 <a:latin typeface="Avenir Next"/>
               </a:rPr>
-              <a:t>Read it as three rules. A 2D image (imaging-MS, an LC×MS heatmap) → patches + linear projection (ViT). A dense 1D signal (a binned spectrum, a chromatogram) → a CNN front-end that emits tokens. A sparse peak list (a handful of m/z + intensity peaks) → peak-as-token (Casanovo).</a:t>
+              <a:t>Same block, three wirings. Encoder-only READS (BERT); encoder–decoder reads then WRITES a new sequence via cross-attention (T5/Flan-T5, Casanovo); decoder-only continues text (GPT, LLaMA). Your turn (60 sec) — pick the family: (a) call a spectrum resistant/susceptible · (b) turn a spectrum into a peptide sequence · (c) draft a free-text QC report. Answers in the notes.</a:t>
             </a:r>
           </a:p>
         </p:txBody>
@@ -5676,7 +5938,7 @@
                 </a:solidFill>
                 <a:latin typeface="Menlo"/>
               </a:rPr>
-              <a:t>A SPECTRUM → TOKENS · YOUR TURN (YOU-DO = Q2)</a:t>
+              <a:t>LECTURE 8 · PART FOUR</a:t>
             </a:r>
           </a:p>
         </p:txBody>
@@ -5689,8 +5951,8 @@
         </p:nvSpPr>
         <p:spPr>
           <a:xfrm>
-            <a:off x="548640" y="731520"/>
-            <a:ext cx="11064240" cy="1005840"/>
+            <a:off x="548640" y="2194560"/>
+            <a:ext cx="11064240" cy="2011680"/>
           </a:xfrm>
           <a:prstGeom prst="rect">
             <a:avLst/>
@@ -5698,68 +5960,58 @@
           <a:noFill/>
         </p:spPr>
         <p:txBody>
-          <a:bodyPr wrap="square" anchor="t">
+          <a:bodyPr wrap="square" anchor="ctr">
             <a:spAutoFit/>
           </a:bodyPr>
           <a:lstStyle/>
           <a:p>
             <a:r>
-              <a:rPr sz="3400" b="1" i="0">
+              <a:rPr sz="4400" b="1" i="0">
                 <a:solidFill>
                   <a:srgbClr val="1B2025"/>
                 </a:solidFill>
                 <a:latin typeface="Avenir Next"/>
               </a:rPr>
-              <a:t>Match each data type to its strategy</a:t>
-            </a:r>
-          </a:p>
-        </p:txBody>
-      </p:sp>
-      <p:pic>
-        <p:nvPicPr>
-          <p:cNvPr id="5" name="Picture 4" descr="fig_tokenization_youdo.png"/>
-          <p:cNvPicPr>
-            <a:picLocks noChangeAspect="1"/>
-          </p:cNvPicPr>
-          <p:nvPr/>
-        </p:nvPicPr>
-        <p:blipFill>
-          <a:blip r:embed="rId2"/>
-          <a:stretch>
-            <a:fillRect/>
-          </a:stretch>
-        </p:blipFill>
-        <p:spPr>
-          <a:xfrm>
-            <a:off x="1774034" y="1828800"/>
-            <a:ext cx="8613452" cy="3566160"/>
-          </a:xfrm>
-          <a:prstGeom prst="rect">
-            <a:avLst/>
-          </a:prstGeom>
-        </p:spPr>
-      </p:pic>
-      <p:sp>
-        <p:nvSpPr>
-          <p:cNvPr id="6" name="Rectangle 5"/>
+              <a:t>How does a spectrum become tokens?</a:t>
+            </a:r>
+          </a:p>
+          <a:p>
+            <a:pPr>
+              <a:spcBef>
+                <a:spcPts val="1600"/>
+              </a:spcBef>
+            </a:pPr>
+            <a:r>
+              <a:rPr sz="2200" b="0" i="0">
+                <a:solidFill>
+                  <a:srgbClr val="0E7C7B"/>
+                </a:solidFill>
+                <a:latin typeface="Avenir Next"/>
+              </a:rPr>
+              <a:t>a transformer eats a sequence of vectors — so what are the vectors for MS data?</a:t>
+            </a:r>
+          </a:p>
+        </p:txBody>
+      </p:sp>
+      <p:sp>
+        <p:nvSpPr>
+          <p:cNvPr id="5" name="Rectangle 4"/>
           <p:cNvSpPr/>
           <p:nvPr/>
         </p:nvSpPr>
         <p:spPr>
           <a:xfrm>
-            <a:off x="548640" y="5486400"/>
-            <a:ext cx="10515600" cy="923544"/>
+            <a:off x="548640" y="2057400"/>
+            <a:ext cx="1280160" cy="54864"/>
           </a:xfrm>
           <a:prstGeom prst="rect">
             <a:avLst/>
           </a:prstGeom>
           <a:solidFill>
-            <a:srgbClr val="F1F1EC"/>
+            <a:srgbClr val="E09E2F"/>
           </a:solidFill>
-          <a:ln w="12700">
-            <a:solidFill>
-              <a:srgbClr val="E09E2F"/>
-            </a:solidFill>
+          <a:ln>
+            <a:noFill/>
           </a:ln>
           <a:effectLst/>
         </p:spPr>
@@ -5778,28 +6030,10 @@
           </a:fontRef>
         </p:style>
         <p:txBody>
-          <a:bodyPr rtlCol="0" anchor="ctr" wrap="square" lIns="182880" rIns="182880"/>
+          <a:bodyPr rtlCol="0" anchor="ctr"/>
           <a:lstStyle/>
           <a:p>
             <a:pPr algn="ctr"/>
-            <a:r>
-              <a:rPr sz="1200" b="1" i="0">
-                <a:solidFill>
-                  <a:srgbClr val="E09E2F"/>
-                </a:solidFill>
-                <a:latin typeface="Menlo"/>
-              </a:rPr>
-              <a:t>CHECKPOINT · </a:t>
-            </a:r>
-            <a:r>
-              <a:rPr sz="1700" b="0" i="0">
-                <a:solidFill>
-                  <a:srgbClr val="3D444C"/>
-                </a:solidFill>
-                <a:latin typeface="Avenir Next"/>
-              </a:rPr>
-              <a:t>Your turn → Quiz 8, Q2. Match each to one strategy (each used once): imaging-MS image · raw binned spectrum · peak list → {patches + linear projection (ViT), CNN front-end, peak-as-token (Casanovo)}. Worked answer in the notes.</a:t>
-            </a:r>
           </a:p>
         </p:txBody>
       </p:sp>
@@ -5894,7 +6128,7 @@
                 </a:solidFill>
                 <a:latin typeface="Menlo"/>
               </a:rPr>
-              <a:t>A SPECTRUM → TOKENS · A REAL SYSTEM</a:t>
+              <a:t>A SPECTRUM → TOKENS · THREE STRATEGIES · I-DO</a:t>
             </a:r>
           </a:p>
         </p:txBody>
@@ -5928,29 +6162,53 @@
                 </a:solidFill>
                 <a:latin typeface="Avenir Next"/>
               </a:rPr>
-              <a:t>Casanovo: a spectrum in, a peptide out</a:t>
-            </a:r>
-          </a:p>
-        </p:txBody>
-      </p:sp>
-      <p:sp>
-        <p:nvSpPr>
-          <p:cNvPr id="5" name="Rounded Rectangle 4"/>
+              <a:t>One spectrum, three ways to tokenize it</a:t>
+            </a:r>
+          </a:p>
+        </p:txBody>
+      </p:sp>
+      <p:pic>
+        <p:nvPicPr>
+          <p:cNvPr id="5" name="Picture 4" descr="fig_tokenization_strategies.png"/>
+          <p:cNvPicPr>
+            <a:picLocks noChangeAspect="1"/>
+          </p:cNvPicPr>
+          <p:nvPr/>
+        </p:nvPicPr>
+        <p:blipFill>
+          <a:blip r:embed="rId2"/>
+          <a:stretch>
+            <a:fillRect/>
+          </a:stretch>
+        </p:blipFill>
+        <p:spPr>
+          <a:xfrm>
+            <a:off x="3258353" y="1828800"/>
+            <a:ext cx="5644813" cy="3358897"/>
+          </a:xfrm>
+          <a:prstGeom prst="rect">
+            <a:avLst/>
+          </a:prstGeom>
+        </p:spPr>
+      </p:pic>
+      <p:sp>
+        <p:nvSpPr>
+          <p:cNvPr id="6" name="Rectangle 5"/>
           <p:cNvSpPr/>
           <p:nvPr/>
         </p:nvSpPr>
         <p:spPr>
           <a:xfrm>
-            <a:off x="548640" y="2743200"/>
-            <a:ext cx="2594610" cy="1371600"/>
-          </a:xfrm>
-          <a:prstGeom prst="roundRect">
+            <a:off x="548640" y="5279137"/>
+            <a:ext cx="10515600" cy="1441703"/>
+          </a:xfrm>
+          <a:prstGeom prst="rect">
             <a:avLst/>
           </a:prstGeom>
           <a:solidFill>
-            <a:srgbClr val="FFFFFF"/>
+            <a:srgbClr val="F1F1EC"/>
           </a:solidFill>
-          <a:ln w="19050">
+          <a:ln w="12700">
             <a:solidFill>
               <a:srgbClr val="3D444C"/>
             </a:solidFill>
@@ -5972,400 +6230,18 @@
           </a:fontRef>
         </p:style>
         <p:txBody>
-          <a:bodyPr rtlCol="0" anchor="ctr" wrap="square"/>
+          <a:bodyPr rtlCol="0" anchor="ctr" wrap="square" lIns="182880" rIns="182880"/>
           <a:lstStyle/>
           <a:p>
             <a:pPr algn="ctr"/>
             <a:r>
-              <a:rPr sz="1800" b="1" i="0">
-                <a:solidFill>
-                  <a:srgbClr val="1B2025"/>
+              <a:rPr sz="1700" b="0" i="0">
+                <a:solidFill>
+                  <a:srgbClr val="3D444C"/>
                 </a:solidFill>
                 <a:latin typeface="Avenir Next"/>
               </a:rPr>
-              <a:t>peak list</a:t>
-            </a:r>
-          </a:p>
-          <a:p>
-            <a:pPr algn="ctr"/>
-            <a:r>
-              <a:rPr sz="1200" b="0" i="0">
-                <a:solidFill>
-                  <a:srgbClr val="8A9099"/>
-                </a:solidFill>
-                <a:latin typeface="Avenir Next"/>
-              </a:rPr>
-              <a:t>each peak → a token</a:t>
-            </a:r>
-          </a:p>
-        </p:txBody>
-      </p:sp>
-      <p:cxnSp>
-        <p:nvCxnSpPr>
-          <p:cNvPr id="6" name="Connector 5"/>
-          <p:cNvCxnSpPr/>
-          <p:nvPr/>
-        </p:nvCxnSpPr>
-        <p:spPr>
-          <a:xfrm>
-            <a:off x="3143250" y="3429000"/>
-            <a:ext cx="228600" cy="0"/>
-          </a:xfrm>
-          <a:prstGeom prst="line">
-            <a:avLst/>
-          </a:prstGeom>
-          <a:ln w="19050">
-            <a:solidFill>
-              <a:srgbClr val="8A9099"/>
-            </a:solidFill>
-          </a:ln>
-        </p:spPr>
-        <p:style>
-          <a:lnRef idx="2">
-            <a:schemeClr val="accent1"/>
-          </a:lnRef>
-          <a:fillRef idx="0">
-            <a:schemeClr val="accent1"/>
-          </a:fillRef>
-          <a:effectRef idx="1">
-            <a:schemeClr val="accent1"/>
-          </a:effectRef>
-          <a:fontRef idx="minor">
-            <a:schemeClr val="tx1"/>
-          </a:fontRef>
-        </p:style>
-      </p:cxnSp>
-      <p:sp>
-        <p:nvSpPr>
-          <p:cNvPr id="7" name="Rounded Rectangle 6"/>
-          <p:cNvSpPr/>
-          <p:nvPr/>
-        </p:nvSpPr>
-        <p:spPr>
-          <a:xfrm>
-            <a:off x="3371850" y="2743200"/>
-            <a:ext cx="2594610" cy="1371600"/>
-          </a:xfrm>
-          <a:prstGeom prst="roundRect">
-            <a:avLst/>
-          </a:prstGeom>
-          <a:solidFill>
-            <a:srgbClr val="FFFFFF"/>
-          </a:solidFill>
-          <a:ln w="31750">
-            <a:solidFill>
-              <a:srgbClr val="0E7C7B"/>
-            </a:solidFill>
-          </a:ln>
-          <a:effectLst/>
-        </p:spPr>
-        <p:style>
-          <a:lnRef idx="1">
-            <a:schemeClr val="accent1"/>
-          </a:lnRef>
-          <a:fillRef idx="3">
-            <a:schemeClr val="accent1"/>
-          </a:fillRef>
-          <a:effectRef idx="2">
-            <a:schemeClr val="accent1"/>
-          </a:effectRef>
-          <a:fontRef idx="minor">
-            <a:schemeClr val="lt1"/>
-          </a:fontRef>
-        </p:style>
-        <p:txBody>
-          <a:bodyPr rtlCol="0" anchor="ctr" wrap="square"/>
-          <a:lstStyle/>
-          <a:p>
-            <a:pPr algn="ctr"/>
-            <a:r>
-              <a:rPr sz="1800" b="1" i="0">
-                <a:solidFill>
-                  <a:srgbClr val="0E7C7B"/>
-                </a:solidFill>
-                <a:latin typeface="Avenir Next"/>
-              </a:rPr>
-              <a:t>encoder</a:t>
-            </a:r>
-          </a:p>
-          <a:p>
-            <a:pPr algn="ctr"/>
-            <a:r>
-              <a:rPr sz="1200" b="0" i="0">
-                <a:solidFill>
-                  <a:srgbClr val="8A9099"/>
-                </a:solidFill>
-                <a:latin typeface="Avenir Next"/>
-              </a:rPr>
-              <a:t>reads all peaks</a:t>
-            </a:r>
-          </a:p>
-        </p:txBody>
-      </p:sp>
-      <p:cxnSp>
-        <p:nvCxnSpPr>
-          <p:cNvPr id="8" name="Connector 7"/>
-          <p:cNvCxnSpPr/>
-          <p:nvPr/>
-        </p:nvCxnSpPr>
-        <p:spPr>
-          <a:xfrm>
-            <a:off x="5966460" y="3429000"/>
-            <a:ext cx="228600" cy="0"/>
-          </a:xfrm>
-          <a:prstGeom prst="line">
-            <a:avLst/>
-          </a:prstGeom>
-          <a:ln w="19050">
-            <a:solidFill>
-              <a:srgbClr val="8A9099"/>
-            </a:solidFill>
-          </a:ln>
-        </p:spPr>
-        <p:style>
-          <a:lnRef idx="2">
-            <a:schemeClr val="accent1"/>
-          </a:lnRef>
-          <a:fillRef idx="0">
-            <a:schemeClr val="accent1"/>
-          </a:fillRef>
-          <a:effectRef idx="1">
-            <a:schemeClr val="accent1"/>
-          </a:effectRef>
-          <a:fontRef idx="minor">
-            <a:schemeClr val="tx1"/>
-          </a:fontRef>
-        </p:style>
-      </p:cxnSp>
-      <p:sp>
-        <p:nvSpPr>
-          <p:cNvPr id="9" name="Rounded Rectangle 8"/>
-          <p:cNvSpPr/>
-          <p:nvPr/>
-        </p:nvSpPr>
-        <p:spPr>
-          <a:xfrm>
-            <a:off x="6195060" y="2743200"/>
-            <a:ext cx="2594610" cy="1371600"/>
-          </a:xfrm>
-          <a:prstGeom prst="roundRect">
-            <a:avLst/>
-          </a:prstGeom>
-          <a:solidFill>
-            <a:srgbClr val="FFFFFF"/>
-          </a:solidFill>
-          <a:ln w="31750">
-            <a:solidFill>
-              <a:srgbClr val="E09E2F"/>
-            </a:solidFill>
-          </a:ln>
-          <a:effectLst/>
-        </p:spPr>
-        <p:style>
-          <a:lnRef idx="1">
-            <a:schemeClr val="accent1"/>
-          </a:lnRef>
-          <a:fillRef idx="3">
-            <a:schemeClr val="accent1"/>
-          </a:fillRef>
-          <a:effectRef idx="2">
-            <a:schemeClr val="accent1"/>
-          </a:effectRef>
-          <a:fontRef idx="minor">
-            <a:schemeClr val="lt1"/>
-          </a:fontRef>
-        </p:style>
-        <p:txBody>
-          <a:bodyPr rtlCol="0" anchor="ctr" wrap="square"/>
-          <a:lstStyle/>
-          <a:p>
-            <a:pPr algn="ctr"/>
-            <a:r>
-              <a:rPr sz="1800" b="1" i="0">
-                <a:solidFill>
-                  <a:srgbClr val="E09E2F"/>
-                </a:solidFill>
-                <a:latin typeface="Avenir Next"/>
-              </a:rPr>
-              <a:t>decoder</a:t>
-            </a:r>
-          </a:p>
-          <a:p>
-            <a:pPr algn="ctr"/>
-            <a:r>
-              <a:rPr sz="1200" b="0" i="0">
-                <a:solidFill>
-                  <a:srgbClr val="8A9099"/>
-                </a:solidFill>
-                <a:latin typeface="Avenir Next"/>
-              </a:rPr>
-              <a:t>writes residues one at a time</a:t>
-            </a:r>
-          </a:p>
-        </p:txBody>
-      </p:sp>
-      <p:cxnSp>
-        <p:nvCxnSpPr>
-          <p:cNvPr id="10" name="Connector 9"/>
-          <p:cNvCxnSpPr/>
-          <p:nvPr/>
-        </p:nvCxnSpPr>
-        <p:spPr>
-          <a:xfrm>
-            <a:off x="8789670" y="3429000"/>
-            <a:ext cx="228600" cy="0"/>
-          </a:xfrm>
-          <a:prstGeom prst="line">
-            <a:avLst/>
-          </a:prstGeom>
-          <a:ln w="19050">
-            <a:solidFill>
-              <a:srgbClr val="8A9099"/>
-            </a:solidFill>
-          </a:ln>
-        </p:spPr>
-        <p:style>
-          <a:lnRef idx="2">
-            <a:schemeClr val="accent1"/>
-          </a:lnRef>
-          <a:fillRef idx="0">
-            <a:schemeClr val="accent1"/>
-          </a:fillRef>
-          <a:effectRef idx="1">
-            <a:schemeClr val="accent1"/>
-          </a:effectRef>
-          <a:fontRef idx="minor">
-            <a:schemeClr val="tx1"/>
-          </a:fontRef>
-        </p:style>
-      </p:cxnSp>
-      <p:sp>
-        <p:nvSpPr>
-          <p:cNvPr id="11" name="Rounded Rectangle 10"/>
-          <p:cNvSpPr/>
-          <p:nvPr/>
-        </p:nvSpPr>
-        <p:spPr>
-          <a:xfrm>
-            <a:off x="9018270" y="2743200"/>
-            <a:ext cx="2594610" cy="1371600"/>
-          </a:xfrm>
-          <a:prstGeom prst="roundRect">
-            <a:avLst/>
-          </a:prstGeom>
-          <a:solidFill>
-            <a:srgbClr val="FFFFFF"/>
-          </a:solidFill>
-          <a:ln w="31750">
-            <a:solidFill>
-              <a:srgbClr val="C4534F"/>
-            </a:solidFill>
-          </a:ln>
-          <a:effectLst/>
-        </p:spPr>
-        <p:style>
-          <a:lnRef idx="1">
-            <a:schemeClr val="accent1"/>
-          </a:lnRef>
-          <a:fillRef idx="3">
-            <a:schemeClr val="accent1"/>
-          </a:fillRef>
-          <a:effectRef idx="2">
-            <a:schemeClr val="accent1"/>
-          </a:effectRef>
-          <a:fontRef idx="minor">
-            <a:schemeClr val="lt1"/>
-          </a:fontRef>
-        </p:style>
-        <p:txBody>
-          <a:bodyPr rtlCol="0" anchor="ctr" wrap="square"/>
-          <a:lstStyle/>
-          <a:p>
-            <a:pPr algn="ctr"/>
-            <a:r>
-              <a:rPr sz="1800" b="1" i="0">
-                <a:solidFill>
-                  <a:srgbClr val="C4534F"/>
-                </a:solidFill>
-                <a:latin typeface="Avenir Next"/>
-              </a:rPr>
-              <a:t>peptide</a:t>
-            </a:r>
-          </a:p>
-          <a:p>
-            <a:pPr algn="ctr"/>
-            <a:r>
-              <a:rPr sz="1200" b="0" i="0">
-                <a:solidFill>
-                  <a:srgbClr val="8A9099"/>
-                </a:solidFill>
-                <a:latin typeface="Avenir Next"/>
-              </a:rPr>
-              <a:t>A-C-D-E-K …</a:t>
-            </a:r>
-          </a:p>
-        </p:txBody>
-      </p:sp>
-      <p:sp>
-        <p:nvSpPr>
-          <p:cNvPr id="12" name="Rectangle 11"/>
-          <p:cNvSpPr/>
-          <p:nvPr/>
-        </p:nvSpPr>
-        <p:spPr>
-          <a:xfrm>
-            <a:off x="548640" y="4937760"/>
-            <a:ext cx="10515600" cy="1441703"/>
-          </a:xfrm>
-          <a:prstGeom prst="rect">
-            <a:avLst/>
-          </a:prstGeom>
-          <a:solidFill>
-            <a:srgbClr val="F1F1EC"/>
-          </a:solidFill>
-          <a:ln w="12700">
-            <a:solidFill>
-              <a:srgbClr val="E09E2F"/>
-            </a:solidFill>
-          </a:ln>
-          <a:effectLst/>
-        </p:spPr>
-        <p:style>
-          <a:lnRef idx="1">
-            <a:schemeClr val="accent1"/>
-          </a:lnRef>
-          <a:fillRef idx="3">
-            <a:schemeClr val="accent1"/>
-          </a:fillRef>
-          <a:effectRef idx="2">
-            <a:schemeClr val="accent1"/>
-          </a:effectRef>
-          <a:fontRef idx="minor">
-            <a:schemeClr val="lt1"/>
-          </a:fontRef>
-        </p:style>
-        <p:txBody>
-          <a:bodyPr rtlCol="0" anchor="ctr" wrap="square" lIns="182880" rIns="182880"/>
-          <a:lstStyle/>
-          <a:p>
-            <a:pPr algn="ctr"/>
-            <a:r>
-              <a:rPr sz="1200" b="1" i="0">
-                <a:solidFill>
-                  <a:srgbClr val="E09E2F"/>
-                </a:solidFill>
-                <a:latin typeface="Menlo"/>
-              </a:rPr>
-              <a:t>PAIR · </a:t>
-            </a:r>
-            <a:r>
-              <a:rPr sz="1700" b="0" i="0">
-                <a:solidFill>
-                  <a:srgbClr val="3D444C"/>
-                </a:solidFill>
-                <a:latin typeface="Avenir Next"/>
-              </a:rPr>
-              <a:t>De novo sequencing as TRANSLATION: the encoder reads the spectrum's peaks (peak-as-token), the decoder writes the peptide residue by residue — the encoder→decoder shape on your MS/MS data (Lab 3's bonus cell touches this family). 💬 Quick (90 sec): why does this need a DECODER, not just an encoder-only classifier? Worked answer in the notes.</a:t>
+              <a:t>(a) Patch + linear projection — cut the signal into equal chunks, project each to a vector (the ViT idea). (b) CNN front-end — slide a small 1D CNN (Lecture 5) that emits a sequence of token embeddings. (c) Peak-as-token — keep only the peaks; each becomes one token carrying its (m/z, intensity). Same spectrum, three sequences of vectors.</a:t>
             </a:r>
           </a:p>
         </p:txBody>
@@ -6461,7 +6337,7 @@
                 </a:solidFill>
                 <a:latin typeface="Menlo"/>
               </a:rPr>
-              <a:t>TRANSFER LEARNING · BORROW A BODY · I-DO</a:t>
+              <a:t>A SPECTRUM → TOKENS · WHICH ONE? · I-DO</a:t>
             </a:r>
           </a:p>
         </p:txBody>
@@ -6475,7 +6351,7 @@
         <p:spPr>
           <a:xfrm>
             <a:off x="548640" y="731520"/>
-            <a:ext cx="11064240" cy="1127760"/>
+            <a:ext cx="11064240" cy="1005840"/>
           </a:xfrm>
           <a:prstGeom prst="rect">
             <a:avLst/>
@@ -6495,14 +6371,14 @@
                 </a:solidFill>
                 <a:latin typeface="Avenir Next"/>
               </a:rPr>
-              <a:t>Don't train from zero — borrow a pretrained body</a:t>
+              <a:t>Which strategy for which data?</a:t>
             </a:r>
           </a:p>
         </p:txBody>
       </p:sp>
       <p:pic>
         <p:nvPicPr>
-          <p:cNvPr id="5" name="Picture 4" descr="fig_transfer_learning.png"/>
+          <p:cNvPr id="5" name="Picture 4" descr="fig_tokenization_decision.png"/>
           <p:cNvPicPr>
             <a:picLocks noChangeAspect="1"/>
           </p:cNvPicPr>
@@ -6516,8 +6392,8 @@
         </p:blipFill>
         <p:spPr>
           <a:xfrm>
-            <a:off x="1962297" y="1828800"/>
-            <a:ext cx="8236925" cy="3617976"/>
+            <a:off x="1711457" y="1828800"/>
+            <a:ext cx="8738605" cy="3617976"/>
           </a:xfrm>
           <a:prstGeom prst="rect">
             <a:avLst/>
@@ -6539,11 +6415,11 @@
             <a:avLst/>
           </a:prstGeom>
           <a:solidFill>
-            <a:srgbClr val="E3F0EF"/>
+            <a:srgbClr val="F1F1EC"/>
           </a:solidFill>
           <a:ln w="12700">
             <a:solidFill>
-              <a:srgbClr val="0E7C7B"/>
+              <a:srgbClr val="3D444C"/>
             </a:solidFill>
           </a:ln>
           <a:effectLst/>
@@ -6568,22 +6444,13 @@
           <a:p>
             <a:pPr algn="ctr"/>
             <a:r>
-              <a:rPr sz="1200" b="1" i="0">
-                <a:solidFill>
-                  <a:srgbClr val="0E7C7B"/>
-                </a:solidFill>
-                <a:latin typeface="Menlo"/>
-              </a:rPr>
-              <a:t>MASS SPEC · </a:t>
-            </a:r>
-            <a:r>
               <a:rPr sz="1700" b="0" i="0">
                 <a:solidFill>
                   <a:srgbClr val="3D444C"/>
                 </a:solidFill>
                 <a:latin typeface="Avenir Next"/>
               </a:rPr>
-              <a:t>Someone pretrained a transformer on MILLIONS of spectra/sequences; its body already learned general features. FREEZE that body (weights kept as-is), bolt on a small NEW head for your task, and train only the head on your few hundred labels. That's transfer learning; training the head (± a little of the body) is fine-tuning.</a:t>
+              <a:t>Read it as three rules. A 2D image (imaging-MS, an LC×MS heatmap) → patches + linear projection (ViT). A dense 1D signal (a binned spectrum, a chromatogram) → a CNN front-end that emits tokens. A sparse peak list (a handful of m/z + intensity peaks) → peak-as-token (Casanovo).</a:t>
             </a:r>
           </a:p>
         </p:txBody>
@@ -6679,7 +6546,7 @@
                 </a:solidFill>
                 <a:latin typeface="Menlo"/>
               </a:rPr>
-              <a:t>TRANSFER LEARNING · WHY IT CHANGES THE GAME</a:t>
+              <a:t>A SPECTRUM → TOKENS · YOUR TURN (YOU-DO = Q3)</a:t>
             </a:r>
           </a:p>
         </p:txBody>
@@ -6713,130 +6580,95 @@
                 </a:solidFill>
                 <a:latin typeface="Avenir Next"/>
               </a:rPr>
-              <a:t>Why 500–800 labeled spectra can be enough</a:t>
-            </a:r>
-          </a:p>
-        </p:txBody>
-      </p:sp>
-      <p:sp>
-        <p:nvSpPr>
-          <p:cNvPr id="5" name="TextBox 4"/>
-          <p:cNvSpPr txBox="1"/>
-          <p:nvPr/>
-        </p:nvSpPr>
-        <p:spPr>
-          <a:xfrm>
-            <a:off x="548640" y="1920240"/>
-            <a:ext cx="10789920" cy="4815840"/>
-          </a:xfrm>
-          <a:prstGeom prst="rect">
-            <a:avLst/>
-          </a:prstGeom>
-          <a:noFill/>
-        </p:spPr>
-        <p:txBody>
-          <a:bodyPr wrap="square" anchor="t">
-            <a:spAutoFit/>
-          </a:bodyPr>
-          <a:lstStyle/>
-          <a:p>
-            <a:pPr>
-              <a:spcAft>
-                <a:spcPts val="1800"/>
-              </a:spcAft>
-            </a:pPr>
-            <a:r>
-              <a:rPr sz="2500" b="1" i="0">
-                <a:solidFill>
-                  <a:srgbClr val="0E7C7B"/>
+              <a:t>Match each data type to its strategy</a:t>
+            </a:r>
+          </a:p>
+        </p:txBody>
+      </p:sp>
+      <p:pic>
+        <p:nvPicPr>
+          <p:cNvPr id="5" name="Picture 4" descr="fig_tokenization_youdo.png"/>
+          <p:cNvPicPr>
+            <a:picLocks noChangeAspect="1"/>
+          </p:cNvPicPr>
+          <p:nvPr/>
+        </p:nvPicPr>
+        <p:blipFill>
+          <a:blip r:embed="rId2"/>
+          <a:stretch>
+            <a:fillRect/>
+          </a:stretch>
+        </p:blipFill>
+        <p:spPr>
+          <a:xfrm>
+            <a:off x="1774034" y="1828800"/>
+            <a:ext cx="8613452" cy="3566160"/>
+          </a:xfrm>
+          <a:prstGeom prst="rect">
+            <a:avLst/>
+          </a:prstGeom>
+        </p:spPr>
+      </p:pic>
+      <p:sp>
+        <p:nvSpPr>
+          <p:cNvPr id="6" name="Rectangle 5"/>
+          <p:cNvSpPr/>
+          <p:nvPr/>
+        </p:nvSpPr>
+        <p:spPr>
+          <a:xfrm>
+            <a:off x="548640" y="5486400"/>
+            <a:ext cx="10515600" cy="923544"/>
+          </a:xfrm>
+          <a:prstGeom prst="rect">
+            <a:avLst/>
+          </a:prstGeom>
+          <a:solidFill>
+            <a:srgbClr val="F1F1EC"/>
+          </a:solidFill>
+          <a:ln w="12700">
+            <a:solidFill>
+              <a:srgbClr val="E09E2F"/>
+            </a:solidFill>
+          </a:ln>
+          <a:effectLst/>
+        </p:spPr>
+        <p:style>
+          <a:lnRef idx="1">
+            <a:schemeClr val="accent1"/>
+          </a:lnRef>
+          <a:fillRef idx="3">
+            <a:schemeClr val="accent1"/>
+          </a:fillRef>
+          <a:effectRef idx="2">
+            <a:schemeClr val="accent1"/>
+          </a:effectRef>
+          <a:fontRef idx="minor">
+            <a:schemeClr val="lt1"/>
+          </a:fontRef>
+        </p:style>
+        <p:txBody>
+          <a:bodyPr rtlCol="0" anchor="ctr" wrap="square" lIns="182880" rIns="182880"/>
+          <a:lstStyle/>
+          <a:p>
+            <a:pPr algn="ctr"/>
+            <a:r>
+              <a:rPr sz="1200" b="1" i="0">
+                <a:solidFill>
+                  <a:srgbClr val="E09E2F"/>
+                </a:solidFill>
+                <a:latin typeface="Menlo"/>
+              </a:rPr>
+              <a:t>CHECKPOINT · </a:t>
+            </a:r>
+            <a:r>
+              <a:rPr sz="1700" b="0" i="0">
+                <a:solidFill>
+                  <a:srgbClr val="3D444C"/>
                 </a:solidFill>
                 <a:latin typeface="Avenir Next"/>
               </a:rPr>
-              <a:t>•  </a:t>
-            </a:r>
-            <a:r>
-              <a:rPr sz="2500" b="0" i="0">
-                <a:solidFill>
-                  <a:srgbClr val="1B2025"/>
-                </a:solidFill>
-                <a:latin typeface="Avenir Next"/>
-              </a:rPr>
-              <a:t>From scratch: millions of weights need a mountain of labels — hundreds of spectra land near the majority-class floor (Lecture 4's overfitting)</a:t>
-            </a:r>
-          </a:p>
-          <a:p>
-            <a:pPr>
-              <a:spcAft>
-                <a:spcPts val="1800"/>
-              </a:spcAft>
-            </a:pPr>
-            <a:r>
-              <a:rPr sz="2500" b="1" i="0">
-                <a:solidFill>
-                  <a:srgbClr val="0E7C7B"/>
-                </a:solidFill>
-                <a:latin typeface="Avenir Next"/>
-              </a:rPr>
-              <a:t>•  </a:t>
-            </a:r>
-            <a:r>
-              <a:rPr sz="2500" b="0" i="0">
-                <a:solidFill>
-                  <a:srgbClr val="1B2025"/>
-                </a:solidFill>
-                <a:latin typeface="Avenir Next"/>
-              </a:rPr>
-              <a:t>Fine-tuning: the body already knows general spectral features — you only fit a SMALL head, so a few hundred labels suffice</a:t>
-            </a:r>
-          </a:p>
-          <a:p>
-            <a:pPr>
-              <a:spcAft>
-                <a:spcPts val="1800"/>
-              </a:spcAft>
-            </a:pPr>
-            <a:r>
-              <a:rPr sz="2500" b="1" i="0">
-                <a:solidFill>
-                  <a:srgbClr val="0E7C7B"/>
-                </a:solidFill>
-                <a:latin typeface="Avenir Next"/>
-              </a:rPr>
-              <a:t>•  </a:t>
-            </a:r>
-            <a:r>
-              <a:rPr sz="2500" b="0" i="0">
-                <a:solidFill>
-                  <a:srgbClr val="1B2025"/>
-                </a:solidFill>
-                <a:latin typeface="Avenir Next"/>
-              </a:rPr>
-              <a:t>Smaller learning rate when fine-tuning — you're nudging good weights, not discovering them from noise</a:t>
-            </a:r>
-          </a:p>
-          <a:p>
-            <a:pPr>
-              <a:spcAft>
-                <a:spcPts val="1800"/>
-              </a:spcAft>
-            </a:pPr>
-            <a:r>
-              <a:rPr sz="2500" b="1" i="0">
-                <a:solidFill>
-                  <a:srgbClr val="0E7C7B"/>
-                </a:solidFill>
-                <a:latin typeface="Avenir Next"/>
-              </a:rPr>
-              <a:t>•  </a:t>
-            </a:r>
-            <a:r>
-              <a:rPr sz="2500" b="0" i="0">
-                <a:solidFill>
-                  <a:srgbClr val="1B2025"/>
-                </a:solidFill>
-                <a:latin typeface="Avenir Next"/>
-              </a:rPr>
-              <a:t>Lab 3 makes it visible: from-scratch ≈ chance, fine-tuned ≈ far better — same data, same afternoon</a:t>
+              <a:t>Your turn → Quiz 8, Q3. Match each to one strategy (each used once): imaging-MS image · raw binned spectrum · peak list → {patches + linear projection (ViT), CNN front-end, peak-as-token (Casanovo)}. Worked answer in the notes.</a:t>
             </a:r>
           </a:p>
         </p:txBody>
@@ -6932,7 +6764,7 @@
                 </a:solidFill>
                 <a:latin typeface="Menlo"/>
               </a:rPr>
-              <a:t>TRANSFER LEARNING · YOUR TURN (YOU-DO = Q3) · 💬 PAIR</a:t>
+              <a:t>A SPECTRUM → TOKENS · A REAL SYSTEM</a:t>
             </a:r>
           </a:p>
         </p:txBody>
@@ -6966,45 +6798,394 @@
                 </a:solidFill>
                 <a:latin typeface="Avenir Next"/>
               </a:rPr>
-              <a:t>Your call: from scratch, or fine-tune?</a:t>
-            </a:r>
-          </a:p>
-        </p:txBody>
-      </p:sp>
-      <p:pic>
-        <p:nvPicPr>
-          <p:cNvPr id="5" name="Picture 4" descr="fig_transfer_learning.png"/>
-          <p:cNvPicPr>
-            <a:picLocks noChangeAspect="1"/>
-          </p:cNvPicPr>
-          <p:nvPr/>
-        </p:nvPicPr>
-        <p:blipFill>
-          <a:blip r:embed="rId2"/>
-          <a:stretch>
-            <a:fillRect/>
-          </a:stretch>
-        </p:blipFill>
-        <p:spPr>
-          <a:xfrm>
-            <a:off x="1709014" y="1828800"/>
-            <a:ext cx="8743492" cy="3840480"/>
-          </a:xfrm>
-          <a:prstGeom prst="rect">
-            <a:avLst/>
-          </a:prstGeom>
-        </p:spPr>
-      </p:pic>
-      <p:sp>
-        <p:nvSpPr>
-          <p:cNvPr id="6" name="Rectangle 5"/>
+              <a:t>Casanovo: a spectrum in, a peptide out</a:t>
+            </a:r>
+          </a:p>
+        </p:txBody>
+      </p:sp>
+      <p:sp>
+        <p:nvSpPr>
+          <p:cNvPr id="5" name="Rounded Rectangle 4"/>
           <p:cNvSpPr/>
           <p:nvPr/>
         </p:nvSpPr>
         <p:spPr>
           <a:xfrm>
-            <a:off x="548640" y="5760720"/>
-            <a:ext cx="10515600" cy="923544"/>
+            <a:off x="548640" y="2743200"/>
+            <a:ext cx="2594610" cy="1371600"/>
+          </a:xfrm>
+          <a:prstGeom prst="roundRect">
+            <a:avLst/>
+          </a:prstGeom>
+          <a:solidFill>
+            <a:srgbClr val="FFFFFF"/>
+          </a:solidFill>
+          <a:ln w="19050">
+            <a:solidFill>
+              <a:srgbClr val="3D444C"/>
+            </a:solidFill>
+          </a:ln>
+          <a:effectLst/>
+        </p:spPr>
+        <p:style>
+          <a:lnRef idx="1">
+            <a:schemeClr val="accent1"/>
+          </a:lnRef>
+          <a:fillRef idx="3">
+            <a:schemeClr val="accent1"/>
+          </a:fillRef>
+          <a:effectRef idx="2">
+            <a:schemeClr val="accent1"/>
+          </a:effectRef>
+          <a:fontRef idx="minor">
+            <a:schemeClr val="lt1"/>
+          </a:fontRef>
+        </p:style>
+        <p:txBody>
+          <a:bodyPr rtlCol="0" anchor="ctr" wrap="square"/>
+          <a:lstStyle/>
+          <a:p>
+            <a:pPr algn="ctr"/>
+            <a:r>
+              <a:rPr sz="1800" b="1" i="0">
+                <a:solidFill>
+                  <a:srgbClr val="1B2025"/>
+                </a:solidFill>
+                <a:latin typeface="Avenir Next"/>
+              </a:rPr>
+              <a:t>peak list</a:t>
+            </a:r>
+          </a:p>
+          <a:p>
+            <a:pPr algn="ctr"/>
+            <a:r>
+              <a:rPr sz="1200" b="0" i="0">
+                <a:solidFill>
+                  <a:srgbClr val="8A9099"/>
+                </a:solidFill>
+                <a:latin typeface="Avenir Next"/>
+              </a:rPr>
+              <a:t>each peak → a token</a:t>
+            </a:r>
+          </a:p>
+        </p:txBody>
+      </p:sp>
+      <p:cxnSp>
+        <p:nvCxnSpPr>
+          <p:cNvPr id="6" name="Connector 5"/>
+          <p:cNvCxnSpPr/>
+          <p:nvPr/>
+        </p:nvCxnSpPr>
+        <p:spPr>
+          <a:xfrm>
+            <a:off x="3143250" y="3429000"/>
+            <a:ext cx="228600" cy="0"/>
+          </a:xfrm>
+          <a:prstGeom prst="line">
+            <a:avLst/>
+          </a:prstGeom>
+          <a:ln w="19050">
+            <a:solidFill>
+              <a:srgbClr val="8A9099"/>
+            </a:solidFill>
+          </a:ln>
+        </p:spPr>
+        <p:style>
+          <a:lnRef idx="2">
+            <a:schemeClr val="accent1"/>
+          </a:lnRef>
+          <a:fillRef idx="0">
+            <a:schemeClr val="accent1"/>
+          </a:fillRef>
+          <a:effectRef idx="1">
+            <a:schemeClr val="accent1"/>
+          </a:effectRef>
+          <a:fontRef idx="minor">
+            <a:schemeClr val="tx1"/>
+          </a:fontRef>
+        </p:style>
+      </p:cxnSp>
+      <p:sp>
+        <p:nvSpPr>
+          <p:cNvPr id="7" name="Rounded Rectangle 6"/>
+          <p:cNvSpPr/>
+          <p:nvPr/>
+        </p:nvSpPr>
+        <p:spPr>
+          <a:xfrm>
+            <a:off x="3371850" y="2743200"/>
+            <a:ext cx="2594610" cy="1371600"/>
+          </a:xfrm>
+          <a:prstGeom prst="roundRect">
+            <a:avLst/>
+          </a:prstGeom>
+          <a:solidFill>
+            <a:srgbClr val="FFFFFF"/>
+          </a:solidFill>
+          <a:ln w="31750">
+            <a:solidFill>
+              <a:srgbClr val="0E7C7B"/>
+            </a:solidFill>
+          </a:ln>
+          <a:effectLst/>
+        </p:spPr>
+        <p:style>
+          <a:lnRef idx="1">
+            <a:schemeClr val="accent1"/>
+          </a:lnRef>
+          <a:fillRef idx="3">
+            <a:schemeClr val="accent1"/>
+          </a:fillRef>
+          <a:effectRef idx="2">
+            <a:schemeClr val="accent1"/>
+          </a:effectRef>
+          <a:fontRef idx="minor">
+            <a:schemeClr val="lt1"/>
+          </a:fontRef>
+        </p:style>
+        <p:txBody>
+          <a:bodyPr rtlCol="0" anchor="ctr" wrap="square"/>
+          <a:lstStyle/>
+          <a:p>
+            <a:pPr algn="ctr"/>
+            <a:r>
+              <a:rPr sz="1800" b="1" i="0">
+                <a:solidFill>
+                  <a:srgbClr val="0E7C7B"/>
+                </a:solidFill>
+                <a:latin typeface="Avenir Next"/>
+              </a:rPr>
+              <a:t>encoder</a:t>
+            </a:r>
+          </a:p>
+          <a:p>
+            <a:pPr algn="ctr"/>
+            <a:r>
+              <a:rPr sz="1200" b="0" i="0">
+                <a:solidFill>
+                  <a:srgbClr val="8A9099"/>
+                </a:solidFill>
+                <a:latin typeface="Avenir Next"/>
+              </a:rPr>
+              <a:t>reads all peaks</a:t>
+            </a:r>
+          </a:p>
+        </p:txBody>
+      </p:sp>
+      <p:cxnSp>
+        <p:nvCxnSpPr>
+          <p:cNvPr id="8" name="Connector 7"/>
+          <p:cNvCxnSpPr/>
+          <p:nvPr/>
+        </p:nvCxnSpPr>
+        <p:spPr>
+          <a:xfrm>
+            <a:off x="5966460" y="3429000"/>
+            <a:ext cx="228600" cy="0"/>
+          </a:xfrm>
+          <a:prstGeom prst="line">
+            <a:avLst/>
+          </a:prstGeom>
+          <a:ln w="19050">
+            <a:solidFill>
+              <a:srgbClr val="8A9099"/>
+            </a:solidFill>
+          </a:ln>
+        </p:spPr>
+        <p:style>
+          <a:lnRef idx="2">
+            <a:schemeClr val="accent1"/>
+          </a:lnRef>
+          <a:fillRef idx="0">
+            <a:schemeClr val="accent1"/>
+          </a:fillRef>
+          <a:effectRef idx="1">
+            <a:schemeClr val="accent1"/>
+          </a:effectRef>
+          <a:fontRef idx="minor">
+            <a:schemeClr val="tx1"/>
+          </a:fontRef>
+        </p:style>
+      </p:cxnSp>
+      <p:sp>
+        <p:nvSpPr>
+          <p:cNvPr id="9" name="Rounded Rectangle 8"/>
+          <p:cNvSpPr/>
+          <p:nvPr/>
+        </p:nvSpPr>
+        <p:spPr>
+          <a:xfrm>
+            <a:off x="6195060" y="2743200"/>
+            <a:ext cx="2594610" cy="1371600"/>
+          </a:xfrm>
+          <a:prstGeom prst="roundRect">
+            <a:avLst/>
+          </a:prstGeom>
+          <a:solidFill>
+            <a:srgbClr val="FFFFFF"/>
+          </a:solidFill>
+          <a:ln w="31750">
+            <a:solidFill>
+              <a:srgbClr val="E09E2F"/>
+            </a:solidFill>
+          </a:ln>
+          <a:effectLst/>
+        </p:spPr>
+        <p:style>
+          <a:lnRef idx="1">
+            <a:schemeClr val="accent1"/>
+          </a:lnRef>
+          <a:fillRef idx="3">
+            <a:schemeClr val="accent1"/>
+          </a:fillRef>
+          <a:effectRef idx="2">
+            <a:schemeClr val="accent1"/>
+          </a:effectRef>
+          <a:fontRef idx="minor">
+            <a:schemeClr val="lt1"/>
+          </a:fontRef>
+        </p:style>
+        <p:txBody>
+          <a:bodyPr rtlCol="0" anchor="ctr" wrap="square"/>
+          <a:lstStyle/>
+          <a:p>
+            <a:pPr algn="ctr"/>
+            <a:r>
+              <a:rPr sz="1800" b="1" i="0">
+                <a:solidFill>
+                  <a:srgbClr val="E09E2F"/>
+                </a:solidFill>
+                <a:latin typeface="Avenir Next"/>
+              </a:rPr>
+              <a:t>decoder</a:t>
+            </a:r>
+          </a:p>
+          <a:p>
+            <a:pPr algn="ctr"/>
+            <a:r>
+              <a:rPr sz="1200" b="0" i="0">
+                <a:solidFill>
+                  <a:srgbClr val="8A9099"/>
+                </a:solidFill>
+                <a:latin typeface="Avenir Next"/>
+              </a:rPr>
+              <a:t>writes residues one at a time</a:t>
+            </a:r>
+          </a:p>
+        </p:txBody>
+      </p:sp>
+      <p:cxnSp>
+        <p:nvCxnSpPr>
+          <p:cNvPr id="10" name="Connector 9"/>
+          <p:cNvCxnSpPr/>
+          <p:nvPr/>
+        </p:nvCxnSpPr>
+        <p:spPr>
+          <a:xfrm>
+            <a:off x="8789670" y="3429000"/>
+            <a:ext cx="228600" cy="0"/>
+          </a:xfrm>
+          <a:prstGeom prst="line">
+            <a:avLst/>
+          </a:prstGeom>
+          <a:ln w="19050">
+            <a:solidFill>
+              <a:srgbClr val="8A9099"/>
+            </a:solidFill>
+          </a:ln>
+        </p:spPr>
+        <p:style>
+          <a:lnRef idx="2">
+            <a:schemeClr val="accent1"/>
+          </a:lnRef>
+          <a:fillRef idx="0">
+            <a:schemeClr val="accent1"/>
+          </a:fillRef>
+          <a:effectRef idx="1">
+            <a:schemeClr val="accent1"/>
+          </a:effectRef>
+          <a:fontRef idx="minor">
+            <a:schemeClr val="tx1"/>
+          </a:fontRef>
+        </p:style>
+      </p:cxnSp>
+      <p:sp>
+        <p:nvSpPr>
+          <p:cNvPr id="11" name="Rounded Rectangle 10"/>
+          <p:cNvSpPr/>
+          <p:nvPr/>
+        </p:nvSpPr>
+        <p:spPr>
+          <a:xfrm>
+            <a:off x="9018270" y="2743200"/>
+            <a:ext cx="2594610" cy="1371600"/>
+          </a:xfrm>
+          <a:prstGeom prst="roundRect">
+            <a:avLst/>
+          </a:prstGeom>
+          <a:solidFill>
+            <a:srgbClr val="FFFFFF"/>
+          </a:solidFill>
+          <a:ln w="31750">
+            <a:solidFill>
+              <a:srgbClr val="C4534F"/>
+            </a:solidFill>
+          </a:ln>
+          <a:effectLst/>
+        </p:spPr>
+        <p:style>
+          <a:lnRef idx="1">
+            <a:schemeClr val="accent1"/>
+          </a:lnRef>
+          <a:fillRef idx="3">
+            <a:schemeClr val="accent1"/>
+          </a:fillRef>
+          <a:effectRef idx="2">
+            <a:schemeClr val="accent1"/>
+          </a:effectRef>
+          <a:fontRef idx="minor">
+            <a:schemeClr val="lt1"/>
+          </a:fontRef>
+        </p:style>
+        <p:txBody>
+          <a:bodyPr rtlCol="0" anchor="ctr" wrap="square"/>
+          <a:lstStyle/>
+          <a:p>
+            <a:pPr algn="ctr"/>
+            <a:r>
+              <a:rPr sz="1800" b="1" i="0">
+                <a:solidFill>
+                  <a:srgbClr val="C4534F"/>
+                </a:solidFill>
+                <a:latin typeface="Avenir Next"/>
+              </a:rPr>
+              <a:t>peptide</a:t>
+            </a:r>
+          </a:p>
+          <a:p>
+            <a:pPr algn="ctr"/>
+            <a:r>
+              <a:rPr sz="1200" b="0" i="0">
+                <a:solidFill>
+                  <a:srgbClr val="8A9099"/>
+                </a:solidFill>
+                <a:latin typeface="Avenir Next"/>
+              </a:rPr>
+              <a:t>A-C-D-E-K …</a:t>
+            </a:r>
+          </a:p>
+        </p:txBody>
+      </p:sp>
+      <p:sp>
+        <p:nvSpPr>
+          <p:cNvPr id="12" name="Rectangle 11"/>
+          <p:cNvSpPr/>
+          <p:nvPr/>
+        </p:nvSpPr>
+        <p:spPr>
+          <a:xfrm>
+            <a:off x="548640" y="4937760"/>
+            <a:ext cx="10515600" cy="1441703"/>
           </a:xfrm>
           <a:prstGeom prst="rect">
             <a:avLst/>
@@ -7045,7 +7226,7 @@
                 </a:solidFill>
                 <a:latin typeface="Menlo"/>
               </a:rPr>
-              <a:t>CHECKPOINT · </a:t>
+              <a:t>PAIR · </a:t>
             </a:r>
             <a:r>
               <a:rPr sz="1700" b="0" i="0">
@@ -7054,7 +7235,7 @@
                 </a:solidFill>
                 <a:latin typeface="Avenir Next"/>
               </a:rPr>
-              <a:t>Your turn → Quiz 8, Q3. 💬 You have 800 labeled spectra and access to a transformer pretrained on 2 million spectra. Train from scratch, or fine-tune? Give one reason. Worked answer in the notes.</a:t>
+              <a:t>De novo sequencing as TRANSLATION: the encoder reads the spectrum's peaks (peak-as-token), the decoder writes the peptide residue by residue — the encoder→decoder shape on your MS/MS data (Lab 3's bonus cell touches this family). 💬 Quick (90 sec): why does this need a DECODER, not just an encoder-only classifier? Worked answer in the notes.</a:t>
             </a:r>
           </a:p>
         </p:txBody>
@@ -7150,7 +7331,7 @@
                 </a:solidFill>
                 <a:latin typeface="Menlo"/>
               </a:rPr>
-              <a:t>LECTURE 8 · WHAT YOU CAN DO NOW</a:t>
+              <a:t>TRANSFER LEARNING · BORROW A BODY · I-DO</a:t>
             </a:r>
           </a:p>
         </p:txBody>
@@ -7164,7 +7345,7 @@
         <p:spPr>
           <a:xfrm>
             <a:off x="548640" y="731520"/>
-            <a:ext cx="11064240" cy="1005840"/>
+            <a:ext cx="11064240" cy="1127760"/>
           </a:xfrm>
           <a:prstGeom prst="rect">
             <a:avLst/>
@@ -7184,134 +7365,35 @@
                 </a:solidFill>
                 <a:latin typeface="Avenir Next"/>
               </a:rPr>
-              <a:t>You can now…</a:t>
-            </a:r>
-          </a:p>
-        </p:txBody>
-      </p:sp>
-      <p:sp>
-        <p:nvSpPr>
-          <p:cNvPr id="5" name="TextBox 4"/>
-          <p:cNvSpPr txBox="1"/>
-          <p:nvPr/>
-        </p:nvSpPr>
-        <p:spPr>
-          <a:xfrm>
-            <a:off x="548640" y="1920240"/>
-            <a:ext cx="10789920" cy="3749039"/>
-          </a:xfrm>
-          <a:prstGeom prst="rect">
-            <a:avLst/>
-          </a:prstGeom>
-          <a:noFill/>
-        </p:spPr>
-        <p:txBody>
-          <a:bodyPr wrap="square" anchor="t">
-            <a:spAutoFit/>
-          </a:bodyPr>
-          <a:lstStyle/>
-          <a:p>
-            <a:pPr>
-              <a:spcAft>
-                <a:spcPts val="1800"/>
-              </a:spcAft>
-            </a:pPr>
-            <a:r>
-              <a:rPr sz="2000" b="1" i="0">
-                <a:solidFill>
-                  <a:srgbClr val="0E7C7B"/>
-                </a:solidFill>
-                <a:latin typeface="Avenir Next"/>
-              </a:rPr>
-              <a:t>•  </a:t>
-            </a:r>
-            <a:r>
-              <a:rPr sz="2000" b="0" i="0">
-                <a:solidFill>
-                  <a:srgbClr val="1B2025"/>
-                </a:solidFill>
-                <a:latin typeface="Avenir Next"/>
-              </a:rPr>
-              <a:t>Say positional encoding's job — attention is order-blind, so add a per-position signal to each token embedding</a:t>
-            </a:r>
-          </a:p>
-          <a:p>
-            <a:pPr>
-              <a:spcAft>
-                <a:spcPts val="1800"/>
-              </a:spcAft>
-            </a:pPr>
-            <a:r>
-              <a:rPr sz="2000" b="1" i="0">
-                <a:solidFill>
-                  <a:srgbClr val="0E7C7B"/>
-                </a:solidFill>
-                <a:latin typeface="Avenir Next"/>
-              </a:rPr>
-              <a:t>•  </a:t>
-            </a:r>
-            <a:r>
-              <a:rPr sz="2000" b="0" i="0">
-                <a:solidFill>
-                  <a:srgbClr val="1B2025"/>
-                </a:solidFill>
-                <a:latin typeface="Avenir Next"/>
-              </a:rPr>
-              <a:t>Distinguish batch vs. layer norm by which axis is averaged, and why transformers use layer norm (Quiz 8 Q4)</a:t>
-            </a:r>
-          </a:p>
-          <a:p>
-            <a:pPr>
-              <a:spcAft>
-                <a:spcPts val="1800"/>
-              </a:spcAft>
-            </a:pPr>
-            <a:r>
-              <a:rPr sz="2000" b="1" i="0">
-                <a:solidFill>
-                  <a:srgbClr val="0E7C7B"/>
-                </a:solidFill>
-                <a:latin typeface="Avenir Next"/>
-              </a:rPr>
-              <a:t>•  </a:t>
-            </a:r>
-            <a:r>
-              <a:rPr sz="2000" b="0" i="0">
-                <a:solidFill>
-                  <a:srgbClr val="1B2025"/>
-                </a:solidFill>
-                <a:latin typeface="Avenir Next"/>
-              </a:rPr>
-              <a:t>Label the four blocks of a transformer (Quiz 8 Q1) — and tell an encoder (reads) from a decoder (writes), BERT vs. GPT</a:t>
-            </a:r>
-          </a:p>
-          <a:p>
-            <a:pPr>
-              <a:spcAft>
-                <a:spcPts val="1800"/>
-              </a:spcAft>
-            </a:pPr>
-            <a:r>
-              <a:rPr sz="2000" b="1" i="0">
-                <a:solidFill>
-                  <a:srgbClr val="0E7C7B"/>
-                </a:solidFill>
-                <a:latin typeface="Avenir Next"/>
-              </a:rPr>
-              <a:t>•  </a:t>
-            </a:r>
-            <a:r>
-              <a:rPr sz="2000" b="0" i="0">
-                <a:solidFill>
-                  <a:srgbClr val="1B2025"/>
-                </a:solidFill>
-                <a:latin typeface="Avenir Next"/>
-              </a:rPr>
-              <a:t>Pick a tokenization for MS data — patches, a CNN front-end, or peak-as-token (Quiz 8 Q2) — and choose fine-tune vs. from-scratch (Quiz 8 Q3)</a:t>
-            </a:r>
-          </a:p>
-        </p:txBody>
-      </p:sp>
+              <a:t>Don't train from zero — borrow a pretrained body</a:t>
+            </a:r>
+          </a:p>
+        </p:txBody>
+      </p:sp>
+      <p:pic>
+        <p:nvPicPr>
+          <p:cNvPr id="5" name="Picture 4" descr="fig_transfer_learning.png"/>
+          <p:cNvPicPr>
+            <a:picLocks noChangeAspect="1"/>
+          </p:cNvPicPr>
+          <p:nvPr/>
+        </p:nvPicPr>
+        <p:blipFill>
+          <a:blip r:embed="rId2"/>
+          <a:stretch>
+            <a:fillRect/>
+          </a:stretch>
+        </p:blipFill>
+        <p:spPr>
+          <a:xfrm>
+            <a:off x="1962297" y="1828800"/>
+            <a:ext cx="8236925" cy="3617976"/>
+          </a:xfrm>
+          <a:prstGeom prst="rect">
+            <a:avLst/>
+          </a:prstGeom>
+        </p:spPr>
+      </p:pic>
       <p:sp>
         <p:nvSpPr>
           <p:cNvPr id="6" name="Rectangle 5"/>
@@ -7320,18 +7402,18 @@
         </p:nvSpPr>
         <p:spPr>
           <a:xfrm>
-            <a:off x="548640" y="5806439"/>
-            <a:ext cx="10515600" cy="923544"/>
+            <a:off x="548640" y="5538216"/>
+            <a:ext cx="10515600" cy="1182624"/>
           </a:xfrm>
           <a:prstGeom prst="rect">
             <a:avLst/>
           </a:prstGeom>
           <a:solidFill>
-            <a:srgbClr val="F1F1EC"/>
+            <a:srgbClr val="E3F0EF"/>
           </a:solidFill>
           <a:ln w="12700">
             <a:solidFill>
-              <a:srgbClr val="3D444C"/>
+              <a:srgbClr val="0E7C7B"/>
             </a:solidFill>
           </a:ln>
           <a:effectLst/>
@@ -7356,13 +7438,22 @@
           <a:p>
             <a:pPr algn="ctr"/>
             <a:r>
+              <a:rPr sz="1200" b="1" i="0">
+                <a:solidFill>
+                  <a:srgbClr val="0E7C7B"/>
+                </a:solidFill>
+                <a:latin typeface="Menlo"/>
+              </a:rPr>
+              <a:t>MASS SPEC · </a:t>
+            </a:r>
+            <a:r>
               <a:rPr sz="1700" b="0" i="0">
                 <a:solidFill>
                   <a:srgbClr val="3D444C"/>
                 </a:solidFill>
                 <a:latin typeface="Avenir Next"/>
               </a:rPr>
-              <a:t>You have now worked every item on Quiz 8 live — label the blocks (Q1), match the tokenizations (Q2), the fine-tune call (Q3), and which-norm-averages-what (Q4). Keep the sheet — Lab 3 fine-tunes a real pretrained transformer next hour.</a:t>
+              <a:t>Someone pretrained a transformer on MILLIONS of spectra/sequences; its body already learned general features. FREEZE that body (weights kept as-is), bolt on a small NEW head for your task, and train only the head on your few hundred labels. That's transfer learning; training the head (± a little of the body) is fine-tuning.</a:t>
             </a:r>
           </a:p>
         </p:txBody>
@@ -7458,7 +7549,7 @@
                 </a:solidFill>
                 <a:latin typeface="Menlo"/>
               </a:rPr>
-              <a:t>LECTURE 8 · OVER TO YOUR LAB</a:t>
+              <a:t>TRANSFER LEARNING · WHY IT CHANGES THE GAME</a:t>
             </a:r>
           </a:p>
         </p:txBody>
@@ -7492,7 +7583,7 @@
                 </a:solidFill>
                 <a:latin typeface="Avenir Next"/>
               </a:rPr>
-              <a:t>Next hour — Lab 3</a:t>
+              <a:t>Why 500–800 labeled spectra can be enough</a:t>
             </a:r>
           </a:p>
         </p:txBody>
@@ -7506,7 +7597,7 @@
         <p:spPr>
           <a:xfrm>
             <a:off x="548640" y="1920240"/>
-            <a:ext cx="10789920" cy="3809999"/>
+            <a:ext cx="10789920" cy="4815840"/>
           </a:xfrm>
           <a:prstGeom prst="rect">
             <a:avLst/>
@@ -7525,7 +7616,7 @@
               </a:spcAft>
             </a:pPr>
             <a:r>
-              <a:rPr sz="2300" b="1" i="0">
+              <a:rPr sz="2500" b="1" i="0">
                 <a:solidFill>
                   <a:srgbClr val="0E7C7B"/>
                 </a:solidFill>
@@ -7534,13 +7625,13 @@
               <a:t>•  </a:t>
             </a:r>
             <a:r>
-              <a:rPr sz="2300" b="0" i="0">
+              <a:rPr sz="2500" b="0" i="0">
                 <a:solidFill>
                   <a:srgbClr val="1B2025"/>
                 </a:solidFill>
                 <a:latin typeface="Avenir Next"/>
               </a:rPr>
-              <a:t>Fine-tune a pretrained transformer (DistilBERT) on a small labeled set — swap the head, freeze the body</a:t>
+              <a:t>From scratch: millions of weights need a mountain of labels — hundreds of spectra land near the majority-class floor (Lecture 4's overfitting)</a:t>
             </a:r>
           </a:p>
           <a:p>
@@ -7550,7 +7641,7 @@
               </a:spcAft>
             </a:pPr>
             <a:r>
-              <a:rPr sz="2300" b="1" i="0">
+              <a:rPr sz="2500" b="1" i="0">
                 <a:solidFill>
                   <a:srgbClr val="0E7C7B"/>
                 </a:solidFill>
@@ -7559,13 +7650,13 @@
               <a:t>•  </a:t>
             </a:r>
             <a:r>
-              <a:rPr sz="2300" b="0" i="0">
+              <a:rPr sz="2500" b="0" i="0">
                 <a:solidFill>
                   <a:srgbClr val="1B2025"/>
                 </a:solidFill>
                 <a:latin typeface="Avenir Next"/>
               </a:rPr>
-              <a:t>Run the three-way race: full fine-tune vs. frozen-body head-only vs. from scratch</a:t>
+              <a:t>Fine-tuning: the body already knows general spectral features — you only fit a SMALL head, so a few hundred labels suffice</a:t>
             </a:r>
           </a:p>
           <a:p>
@@ -7575,7 +7666,7 @@
               </a:spcAft>
             </a:pPr>
             <a:r>
-              <a:rPr sz="2300" b="1" i="0">
+              <a:rPr sz="2500" b="1" i="0">
                 <a:solidFill>
                   <a:srgbClr val="0E7C7B"/>
                 </a:solidFill>
@@ -7584,13 +7675,13 @@
               <a:t>•  </a:t>
             </a:r>
             <a:r>
-              <a:rPr sz="2300" b="0" i="0">
+              <a:rPr sz="2500" b="0" i="0">
                 <a:solidFill>
                   <a:srgbClr val="1B2025"/>
                 </a:solidFill>
                 <a:latin typeface="Avenir Next"/>
               </a:rPr>
-              <a:t>Watch from-scratch stall near chance while fine-tuning wins — on the same small data</a:t>
+              <a:t>Smaller learning rate when fine-tuning — you're nudging good weights, not discovering them from noise</a:t>
             </a:r>
           </a:p>
           <a:p>
@@ -7600,7 +7691,7 @@
               </a:spcAft>
             </a:pPr>
             <a:r>
-              <a:rPr sz="2300" b="1" i="0">
+              <a:rPr sz="2500" b="1" i="0">
                 <a:solidFill>
                   <a:srgbClr val="0E7C7B"/>
                 </a:solidFill>
@@ -7609,77 +7700,13 @@
               <a:t>•  </a:t>
             </a:r>
             <a:r>
-              <a:rPr sz="2300" b="0" i="0">
+              <a:rPr sz="2500" b="0" i="0">
                 <a:solidFill>
                   <a:srgbClr val="1B2025"/>
                 </a:solidFill>
                 <a:latin typeface="Avenir Next"/>
               </a:rPr>
-              <a:t>Bonus: the same recipe on ESM-2, a protein language model, classifying peptides</a:t>
-            </a:r>
-          </a:p>
-        </p:txBody>
-      </p:sp>
-      <p:sp>
-        <p:nvSpPr>
-          <p:cNvPr id="6" name="Rectangle 5"/>
-          <p:cNvSpPr/>
-          <p:nvPr/>
-        </p:nvSpPr>
-        <p:spPr>
-          <a:xfrm>
-            <a:off x="548640" y="5843016"/>
-            <a:ext cx="10515600" cy="923544"/>
-          </a:xfrm>
-          <a:prstGeom prst="rect">
-            <a:avLst/>
-          </a:prstGeom>
-          <a:solidFill>
-            <a:srgbClr val="F1F1EC"/>
-          </a:solidFill>
-          <a:ln w="12700">
-            <a:solidFill>
-              <a:srgbClr val="E09E2F"/>
-            </a:solidFill>
-          </a:ln>
-          <a:effectLst/>
-        </p:spPr>
-        <p:style>
-          <a:lnRef idx="1">
-            <a:schemeClr val="accent1"/>
-          </a:lnRef>
-          <a:fillRef idx="3">
-            <a:schemeClr val="accent1"/>
-          </a:fillRef>
-          <a:effectRef idx="2">
-            <a:schemeClr val="accent1"/>
-          </a:effectRef>
-          <a:fontRef idx="minor">
-            <a:schemeClr val="lt1"/>
-          </a:fontRef>
-        </p:style>
-        <p:txBody>
-          <a:bodyPr rtlCol="0" anchor="ctr" wrap="square" lIns="182880" rIns="182880"/>
-          <a:lstStyle/>
-          <a:p>
-            <a:pPr algn="ctr"/>
-            <a:r>
-              <a:rPr sz="1200" b="1" i="0">
-                <a:solidFill>
-                  <a:srgbClr val="E09E2F"/>
-                </a:solidFill>
-                <a:latin typeface="Menlo"/>
-              </a:rPr>
-              <a:t>CHECKPOINT · </a:t>
-            </a:r>
-            <a:r>
-              <a:rPr sz="1700" b="0" i="0">
-                <a:solidFill>
-                  <a:srgbClr val="3D444C"/>
-                </a:solidFill>
-                <a:latin typeface="Avenir Next"/>
-              </a:rPr>
-              <a:t>2 minutes to finish Quiz 8 solo while Colab boots → we mark it together as Lab 3 opens. The first blank you'll fill is the classification HEAD you bolt onto a frozen pretrained body — exactly the move from the last slide.</a:t>
+              <a:t>Lab 3 makes it visible: from-scratch ≈ chance, fine-tuned ≈ far better — same data, same afternoon</a:t>
             </a:r>
           </a:p>
         </p:txBody>
@@ -7857,7 +7884,7 @@
                 </a:solidFill>
                 <a:latin typeface="Avenir Next"/>
               </a:rPr>
-              <a:t>Positional encoding — attention is order-blind, so inject position</a:t>
+              <a:t>Positional encoding — inject order: sinusoidal 'clocks' + relative (RoPE)</a:t>
             </a:r>
             <a:r>
               <a:rPr sz="1800" b="0" i="0">
@@ -7866,7 +7893,7 @@
                 </a:solidFill>
                 <a:latin typeface="Menlo"/>
               </a:rPr>
-              <a:t>   · 10 min</a:t>
+              <a:t>   · 12 min</a:t>
             </a:r>
           </a:p>
           <a:p>
@@ -7900,7 +7927,7 @@
                 </a:solidFill>
                 <a:latin typeface="Menlo"/>
               </a:rPr>
-              <a:t>   · 8 min</a:t>
+              <a:t>   · 6 min</a:t>
             </a:r>
           </a:p>
           <a:p>
@@ -7925,7 +7952,7 @@
                 </a:solidFill>
                 <a:latin typeface="Avenir Next"/>
               </a:rPr>
-              <a:t>Assembling the block; encoder vs. decoder; BERT vs. GPT</a:t>
+              <a:t>Assemble the block; encoder / encoder–decoder / decoder-only + cross-attention</a:t>
             </a:r>
             <a:r>
               <a:rPr sz="1800" b="0" i="0">
@@ -7934,7 +7961,7 @@
                 </a:solidFill>
                 <a:latin typeface="Menlo"/>
               </a:rPr>
-              <a:t>   · 12 min</a:t>
+              <a:t>   · 15 min</a:t>
             </a:r>
           </a:p>
           <a:p>
@@ -8003,6 +8030,849 @@
                 <a:latin typeface="Menlo"/>
               </a:rPr>
               <a:t>   · 13 min</a:t>
+            </a:r>
+          </a:p>
+        </p:txBody>
+      </p:sp>
+    </p:spTree>
+  </p:cSld>
+  <p:clrMapOvr>
+    <a:masterClrMapping/>
+  </p:clrMapOvr>
+</p:sld>
+</file>
+
+<file path=ppt/slides/slide20.xml><?xml version="1.0" encoding="utf-8"?>
+<p:sld xmlns:a="http://schemas.openxmlformats.org/drawingml/2006/main" xmlns:p="http://schemas.openxmlformats.org/presentationml/2006/main" xmlns:r="http://schemas.openxmlformats.org/officeDocument/2006/relationships">
+  <p:cSld>
+    <p:spTree>
+      <p:nvGrpSpPr>
+        <p:cNvPr id="1" name=""/>
+        <p:cNvGrpSpPr/>
+        <p:nvPr/>
+      </p:nvGrpSpPr>
+      <p:grpSpPr/>
+      <p:sp>
+        <p:nvSpPr>
+          <p:cNvPr id="2" name="Rectangle 1"/>
+          <p:cNvSpPr/>
+          <p:nvPr/>
+        </p:nvSpPr>
+        <p:spPr>
+          <a:xfrm>
+            <a:off x="0" y="0"/>
+            <a:ext cx="12191695" cy="6858000"/>
+          </a:xfrm>
+          <a:prstGeom prst="rect">
+            <a:avLst/>
+          </a:prstGeom>
+          <a:solidFill>
+            <a:srgbClr val="FBFBF8"/>
+          </a:solidFill>
+          <a:ln>
+            <a:noFill/>
+          </a:ln>
+          <a:effectLst/>
+        </p:spPr>
+        <p:style>
+          <a:lnRef idx="1">
+            <a:schemeClr val="accent1"/>
+          </a:lnRef>
+          <a:fillRef idx="3">
+            <a:schemeClr val="accent1"/>
+          </a:fillRef>
+          <a:effectRef idx="2">
+            <a:schemeClr val="accent1"/>
+          </a:effectRef>
+          <a:fontRef idx="minor">
+            <a:schemeClr val="lt1"/>
+          </a:fontRef>
+        </p:style>
+        <p:txBody>
+          <a:bodyPr rtlCol="0" anchor="ctr"/>
+          <a:lstStyle/>
+          <a:p>
+            <a:pPr algn="ctr"/>
+          </a:p>
+        </p:txBody>
+      </p:sp>
+      <p:sp>
+        <p:nvSpPr>
+          <p:cNvPr id="3" name="TextBox 2"/>
+          <p:cNvSpPr txBox="1"/>
+          <p:nvPr/>
+        </p:nvSpPr>
+        <p:spPr>
+          <a:xfrm>
+            <a:off x="548640" y="320040"/>
+            <a:ext cx="10972800" cy="365760"/>
+          </a:xfrm>
+          <a:prstGeom prst="rect">
+            <a:avLst/>
+          </a:prstGeom>
+          <a:noFill/>
+        </p:spPr>
+        <p:txBody>
+          <a:bodyPr wrap="square" anchor="t">
+            <a:spAutoFit/>
+          </a:bodyPr>
+          <a:lstStyle/>
+          <a:p>
+            <a:r>
+              <a:rPr sz="1300" b="1" i="0">
+                <a:solidFill>
+                  <a:srgbClr val="8A9099"/>
+                </a:solidFill>
+                <a:latin typeface="Menlo"/>
+              </a:rPr>
+              <a:t>TRANSFER LEARNING · YOUR TURN (YOU-DO = Q4) · 💬 PAIR</a:t>
+            </a:r>
+          </a:p>
+        </p:txBody>
+      </p:sp>
+      <p:sp>
+        <p:nvSpPr>
+          <p:cNvPr id="4" name="TextBox 3"/>
+          <p:cNvSpPr txBox="1"/>
+          <p:nvPr/>
+        </p:nvSpPr>
+        <p:spPr>
+          <a:xfrm>
+            <a:off x="548640" y="731520"/>
+            <a:ext cx="11064240" cy="1005840"/>
+          </a:xfrm>
+          <a:prstGeom prst="rect">
+            <a:avLst/>
+          </a:prstGeom>
+          <a:noFill/>
+        </p:spPr>
+        <p:txBody>
+          <a:bodyPr wrap="square" anchor="t">
+            <a:spAutoFit/>
+          </a:bodyPr>
+          <a:lstStyle/>
+          <a:p>
+            <a:r>
+              <a:rPr sz="3400" b="1" i="0">
+                <a:solidFill>
+                  <a:srgbClr val="1B2025"/>
+                </a:solidFill>
+                <a:latin typeface="Avenir Next"/>
+              </a:rPr>
+              <a:t>Your call: from scratch, or fine-tune?</a:t>
+            </a:r>
+          </a:p>
+        </p:txBody>
+      </p:sp>
+      <p:pic>
+        <p:nvPicPr>
+          <p:cNvPr id="5" name="Picture 4" descr="fig_transfer_learning.png"/>
+          <p:cNvPicPr>
+            <a:picLocks noChangeAspect="1"/>
+          </p:cNvPicPr>
+          <p:nvPr/>
+        </p:nvPicPr>
+        <p:blipFill>
+          <a:blip r:embed="rId2"/>
+          <a:stretch>
+            <a:fillRect/>
+          </a:stretch>
+        </p:blipFill>
+        <p:spPr>
+          <a:xfrm>
+            <a:off x="1709014" y="1828800"/>
+            <a:ext cx="8743492" cy="3840480"/>
+          </a:xfrm>
+          <a:prstGeom prst="rect">
+            <a:avLst/>
+          </a:prstGeom>
+        </p:spPr>
+      </p:pic>
+      <p:sp>
+        <p:nvSpPr>
+          <p:cNvPr id="6" name="Rectangle 5"/>
+          <p:cNvSpPr/>
+          <p:nvPr/>
+        </p:nvSpPr>
+        <p:spPr>
+          <a:xfrm>
+            <a:off x="548640" y="5760720"/>
+            <a:ext cx="10515600" cy="923544"/>
+          </a:xfrm>
+          <a:prstGeom prst="rect">
+            <a:avLst/>
+          </a:prstGeom>
+          <a:solidFill>
+            <a:srgbClr val="F1F1EC"/>
+          </a:solidFill>
+          <a:ln w="12700">
+            <a:solidFill>
+              <a:srgbClr val="E09E2F"/>
+            </a:solidFill>
+          </a:ln>
+          <a:effectLst/>
+        </p:spPr>
+        <p:style>
+          <a:lnRef idx="1">
+            <a:schemeClr val="accent1"/>
+          </a:lnRef>
+          <a:fillRef idx="3">
+            <a:schemeClr val="accent1"/>
+          </a:fillRef>
+          <a:effectRef idx="2">
+            <a:schemeClr val="accent1"/>
+          </a:effectRef>
+          <a:fontRef idx="minor">
+            <a:schemeClr val="lt1"/>
+          </a:fontRef>
+        </p:style>
+        <p:txBody>
+          <a:bodyPr rtlCol="0" anchor="ctr" wrap="square" lIns="182880" rIns="182880"/>
+          <a:lstStyle/>
+          <a:p>
+            <a:pPr algn="ctr"/>
+            <a:r>
+              <a:rPr sz="1200" b="1" i="0">
+                <a:solidFill>
+                  <a:srgbClr val="E09E2F"/>
+                </a:solidFill>
+                <a:latin typeface="Menlo"/>
+              </a:rPr>
+              <a:t>CHECKPOINT · </a:t>
+            </a:r>
+            <a:r>
+              <a:rPr sz="1700" b="0" i="0">
+                <a:solidFill>
+                  <a:srgbClr val="3D444C"/>
+                </a:solidFill>
+                <a:latin typeface="Avenir Next"/>
+              </a:rPr>
+              <a:t>Your turn → Quiz 8, Q4. 💬 You have 800 labeled spectra and access to a transformer pretrained on 2 million spectra. Train from scratch, or fine-tune? Give one reason. Worked answer in the notes.</a:t>
+            </a:r>
+          </a:p>
+        </p:txBody>
+      </p:sp>
+    </p:spTree>
+  </p:cSld>
+  <p:clrMapOvr>
+    <a:masterClrMapping/>
+  </p:clrMapOvr>
+</p:sld>
+</file>
+
+<file path=ppt/slides/slide21.xml><?xml version="1.0" encoding="utf-8"?>
+<p:sld xmlns:a="http://schemas.openxmlformats.org/drawingml/2006/main" xmlns:p="http://schemas.openxmlformats.org/presentationml/2006/main" xmlns:r="http://schemas.openxmlformats.org/officeDocument/2006/relationships">
+  <p:cSld>
+    <p:spTree>
+      <p:nvGrpSpPr>
+        <p:cNvPr id="1" name=""/>
+        <p:cNvGrpSpPr/>
+        <p:nvPr/>
+      </p:nvGrpSpPr>
+      <p:grpSpPr/>
+      <p:sp>
+        <p:nvSpPr>
+          <p:cNvPr id="2" name="Rectangle 1"/>
+          <p:cNvSpPr/>
+          <p:nvPr/>
+        </p:nvSpPr>
+        <p:spPr>
+          <a:xfrm>
+            <a:off x="0" y="0"/>
+            <a:ext cx="12191695" cy="6858000"/>
+          </a:xfrm>
+          <a:prstGeom prst="rect">
+            <a:avLst/>
+          </a:prstGeom>
+          <a:solidFill>
+            <a:srgbClr val="FBFBF8"/>
+          </a:solidFill>
+          <a:ln>
+            <a:noFill/>
+          </a:ln>
+          <a:effectLst/>
+        </p:spPr>
+        <p:style>
+          <a:lnRef idx="1">
+            <a:schemeClr val="accent1"/>
+          </a:lnRef>
+          <a:fillRef idx="3">
+            <a:schemeClr val="accent1"/>
+          </a:fillRef>
+          <a:effectRef idx="2">
+            <a:schemeClr val="accent1"/>
+          </a:effectRef>
+          <a:fontRef idx="minor">
+            <a:schemeClr val="lt1"/>
+          </a:fontRef>
+        </p:style>
+        <p:txBody>
+          <a:bodyPr rtlCol="0" anchor="ctr"/>
+          <a:lstStyle/>
+          <a:p>
+            <a:pPr algn="ctr"/>
+          </a:p>
+        </p:txBody>
+      </p:sp>
+      <p:sp>
+        <p:nvSpPr>
+          <p:cNvPr id="3" name="TextBox 2"/>
+          <p:cNvSpPr txBox="1"/>
+          <p:nvPr/>
+        </p:nvSpPr>
+        <p:spPr>
+          <a:xfrm>
+            <a:off x="548640" y="320040"/>
+            <a:ext cx="10972800" cy="365760"/>
+          </a:xfrm>
+          <a:prstGeom prst="rect">
+            <a:avLst/>
+          </a:prstGeom>
+          <a:noFill/>
+        </p:spPr>
+        <p:txBody>
+          <a:bodyPr wrap="square" anchor="t">
+            <a:spAutoFit/>
+          </a:bodyPr>
+          <a:lstStyle/>
+          <a:p>
+            <a:r>
+              <a:rPr sz="1300" b="1" i="0">
+                <a:solidFill>
+                  <a:srgbClr val="8A9099"/>
+                </a:solidFill>
+                <a:latin typeface="Menlo"/>
+              </a:rPr>
+              <a:t>LECTURE 8 · WHAT YOU CAN DO NOW</a:t>
+            </a:r>
+          </a:p>
+        </p:txBody>
+      </p:sp>
+      <p:sp>
+        <p:nvSpPr>
+          <p:cNvPr id="4" name="TextBox 3"/>
+          <p:cNvSpPr txBox="1"/>
+          <p:nvPr/>
+        </p:nvSpPr>
+        <p:spPr>
+          <a:xfrm>
+            <a:off x="548640" y="731520"/>
+            <a:ext cx="11064240" cy="1005840"/>
+          </a:xfrm>
+          <a:prstGeom prst="rect">
+            <a:avLst/>
+          </a:prstGeom>
+          <a:noFill/>
+        </p:spPr>
+        <p:txBody>
+          <a:bodyPr wrap="square" anchor="t">
+            <a:spAutoFit/>
+          </a:bodyPr>
+          <a:lstStyle/>
+          <a:p>
+            <a:r>
+              <a:rPr sz="3400" b="1" i="0">
+                <a:solidFill>
+                  <a:srgbClr val="1B2025"/>
+                </a:solidFill>
+                <a:latin typeface="Avenir Next"/>
+              </a:rPr>
+              <a:t>You can now…</a:t>
+            </a:r>
+          </a:p>
+        </p:txBody>
+      </p:sp>
+      <p:sp>
+        <p:nvSpPr>
+          <p:cNvPr id="5" name="TextBox 4"/>
+          <p:cNvSpPr txBox="1"/>
+          <p:nvPr/>
+        </p:nvSpPr>
+        <p:spPr>
+          <a:xfrm>
+            <a:off x="548640" y="1920240"/>
+            <a:ext cx="10789920" cy="3474720"/>
+          </a:xfrm>
+          <a:prstGeom prst="rect">
+            <a:avLst/>
+          </a:prstGeom>
+          <a:noFill/>
+        </p:spPr>
+        <p:txBody>
+          <a:bodyPr wrap="square" anchor="t">
+            <a:spAutoFit/>
+          </a:bodyPr>
+          <a:lstStyle/>
+          <a:p>
+            <a:pPr>
+              <a:spcAft>
+                <a:spcPts val="1800"/>
+              </a:spcAft>
+            </a:pPr>
+            <a:r>
+              <a:rPr sz="1800" b="1" i="0">
+                <a:solidFill>
+                  <a:srgbClr val="0E7C7B"/>
+                </a:solidFill>
+                <a:latin typeface="Avenir Next"/>
+              </a:rPr>
+              <a:t>•  </a:t>
+            </a:r>
+            <a:r>
+              <a:rPr sz="1800" b="0" i="0">
+                <a:solidFill>
+                  <a:srgbClr val="1B2025"/>
+                </a:solidFill>
+                <a:latin typeface="Avenir Next"/>
+              </a:rPr>
+              <a:t>Explain positional encoding — attention is order-blind, so add a per-position signal: sinusoidal 'clocks' (absolute) or RoPE (relative — encode the gap)</a:t>
+            </a:r>
+          </a:p>
+          <a:p>
+            <a:pPr>
+              <a:spcAft>
+                <a:spcPts val="1800"/>
+              </a:spcAft>
+            </a:pPr>
+            <a:r>
+              <a:rPr sz="1800" b="1" i="0">
+                <a:solidFill>
+                  <a:srgbClr val="0E7C7B"/>
+                </a:solidFill>
+                <a:latin typeface="Avenir Next"/>
+              </a:rPr>
+              <a:t>•  </a:t>
+            </a:r>
+            <a:r>
+              <a:rPr sz="1800" b="0" i="0">
+                <a:solidFill>
+                  <a:srgbClr val="1B2025"/>
+                </a:solidFill>
+                <a:latin typeface="Avenir Next"/>
+              </a:rPr>
+              <a:t>Explain that a token's CONTEXT is a blend of the values, and that cross-attention lets a decoder read the encoder's K,V — its memory of the input (Quiz 8 Q1–Q2)</a:t>
+            </a:r>
+          </a:p>
+          <a:p>
+            <a:pPr>
+              <a:spcAft>
+                <a:spcPts val="1800"/>
+              </a:spcAft>
+            </a:pPr>
+            <a:r>
+              <a:rPr sz="1800" b="1" i="0">
+                <a:solidFill>
+                  <a:srgbClr val="0E7C7B"/>
+                </a:solidFill>
+                <a:latin typeface="Avenir Next"/>
+              </a:rPr>
+              <a:t>•  </a:t>
+            </a:r>
+            <a:r>
+              <a:rPr sz="1800" b="0" i="0">
+                <a:solidFill>
+                  <a:srgbClr val="1B2025"/>
+                </a:solidFill>
+                <a:latin typeface="Avenir Next"/>
+              </a:rPr>
+              <a:t>Tell the three families apart — encoder-only reads (BERT), encoder–decoder reads→writes via cross-attention (T5/Flan-T5, Casanovo), decoder-only writes (GPT, LLaMA)</a:t>
+            </a:r>
+          </a:p>
+          <a:p>
+            <a:pPr>
+              <a:spcAft>
+                <a:spcPts val="1800"/>
+              </a:spcAft>
+            </a:pPr>
+            <a:r>
+              <a:rPr sz="1800" b="1" i="0">
+                <a:solidFill>
+                  <a:srgbClr val="0E7C7B"/>
+                </a:solidFill>
+                <a:latin typeface="Avenir Next"/>
+              </a:rPr>
+              <a:t>•  </a:t>
+            </a:r>
+            <a:r>
+              <a:rPr sz="1800" b="0" i="0">
+                <a:solidFill>
+                  <a:srgbClr val="1B2025"/>
+                </a:solidFill>
+                <a:latin typeface="Avenir Next"/>
+              </a:rPr>
+              <a:t>Pick a tokenization for MS data — patches, a CNN front-end, or peak-as-token (Quiz 8 Q3) — and choose fine-tune vs. from-scratch (Quiz 8 Q4)</a:t>
+            </a:r>
+          </a:p>
+        </p:txBody>
+      </p:sp>
+      <p:sp>
+        <p:nvSpPr>
+          <p:cNvPr id="6" name="Rectangle 5"/>
+          <p:cNvSpPr/>
+          <p:nvPr/>
+        </p:nvSpPr>
+        <p:spPr>
+          <a:xfrm>
+            <a:off x="548640" y="5532120"/>
+            <a:ext cx="10515600" cy="1182624"/>
+          </a:xfrm>
+          <a:prstGeom prst="rect">
+            <a:avLst/>
+          </a:prstGeom>
+          <a:solidFill>
+            <a:srgbClr val="F1F1EC"/>
+          </a:solidFill>
+          <a:ln w="12700">
+            <a:solidFill>
+              <a:srgbClr val="3D444C"/>
+            </a:solidFill>
+          </a:ln>
+          <a:effectLst/>
+        </p:spPr>
+        <p:style>
+          <a:lnRef idx="1">
+            <a:schemeClr val="accent1"/>
+          </a:lnRef>
+          <a:fillRef idx="3">
+            <a:schemeClr val="accent1"/>
+          </a:fillRef>
+          <a:effectRef idx="2">
+            <a:schemeClr val="accent1"/>
+          </a:effectRef>
+          <a:fontRef idx="minor">
+            <a:schemeClr val="lt1"/>
+          </a:fontRef>
+        </p:style>
+        <p:txBody>
+          <a:bodyPr rtlCol="0" anchor="ctr" wrap="square" lIns="182880" rIns="182880"/>
+          <a:lstStyle/>
+          <a:p>
+            <a:pPr algn="ctr"/>
+            <a:r>
+              <a:rPr sz="1700" b="0" i="0">
+                <a:solidFill>
+                  <a:srgbClr val="3D444C"/>
+                </a:solidFill>
+                <a:latin typeface="Avenir Next"/>
+              </a:rPr>
+              <a:t>You have now worked every item on Quiz 8 live — context is the values (Q1), the encoder's K,V is the cross-attention context (Q2), match the tokenizations (Q3), and the fine-tune call (Q4). Keep the sheet — Lab 3 fine-tunes a real pretrained transformer next hour.</a:t>
+            </a:r>
+          </a:p>
+        </p:txBody>
+      </p:sp>
+    </p:spTree>
+  </p:cSld>
+  <p:clrMapOvr>
+    <a:masterClrMapping/>
+  </p:clrMapOvr>
+</p:sld>
+</file>
+
+<file path=ppt/slides/slide22.xml><?xml version="1.0" encoding="utf-8"?>
+<p:sld xmlns:a="http://schemas.openxmlformats.org/drawingml/2006/main" xmlns:p="http://schemas.openxmlformats.org/presentationml/2006/main" xmlns:r="http://schemas.openxmlformats.org/officeDocument/2006/relationships">
+  <p:cSld>
+    <p:spTree>
+      <p:nvGrpSpPr>
+        <p:cNvPr id="1" name=""/>
+        <p:cNvGrpSpPr/>
+        <p:nvPr/>
+      </p:nvGrpSpPr>
+      <p:grpSpPr/>
+      <p:sp>
+        <p:nvSpPr>
+          <p:cNvPr id="2" name="Rectangle 1"/>
+          <p:cNvSpPr/>
+          <p:nvPr/>
+        </p:nvSpPr>
+        <p:spPr>
+          <a:xfrm>
+            <a:off x="0" y="0"/>
+            <a:ext cx="12191695" cy="6858000"/>
+          </a:xfrm>
+          <a:prstGeom prst="rect">
+            <a:avLst/>
+          </a:prstGeom>
+          <a:solidFill>
+            <a:srgbClr val="FBFBF8"/>
+          </a:solidFill>
+          <a:ln>
+            <a:noFill/>
+          </a:ln>
+          <a:effectLst/>
+        </p:spPr>
+        <p:style>
+          <a:lnRef idx="1">
+            <a:schemeClr val="accent1"/>
+          </a:lnRef>
+          <a:fillRef idx="3">
+            <a:schemeClr val="accent1"/>
+          </a:fillRef>
+          <a:effectRef idx="2">
+            <a:schemeClr val="accent1"/>
+          </a:effectRef>
+          <a:fontRef idx="minor">
+            <a:schemeClr val="lt1"/>
+          </a:fontRef>
+        </p:style>
+        <p:txBody>
+          <a:bodyPr rtlCol="0" anchor="ctr"/>
+          <a:lstStyle/>
+          <a:p>
+            <a:pPr algn="ctr"/>
+          </a:p>
+        </p:txBody>
+      </p:sp>
+      <p:sp>
+        <p:nvSpPr>
+          <p:cNvPr id="3" name="TextBox 2"/>
+          <p:cNvSpPr txBox="1"/>
+          <p:nvPr/>
+        </p:nvSpPr>
+        <p:spPr>
+          <a:xfrm>
+            <a:off x="548640" y="320040"/>
+            <a:ext cx="10972800" cy="365760"/>
+          </a:xfrm>
+          <a:prstGeom prst="rect">
+            <a:avLst/>
+          </a:prstGeom>
+          <a:noFill/>
+        </p:spPr>
+        <p:txBody>
+          <a:bodyPr wrap="square" anchor="t">
+            <a:spAutoFit/>
+          </a:bodyPr>
+          <a:lstStyle/>
+          <a:p>
+            <a:r>
+              <a:rPr sz="1300" b="1" i="0">
+                <a:solidFill>
+                  <a:srgbClr val="8A9099"/>
+                </a:solidFill>
+                <a:latin typeface="Menlo"/>
+              </a:rPr>
+              <a:t>LECTURE 8 · OVER TO YOUR LAB</a:t>
+            </a:r>
+          </a:p>
+        </p:txBody>
+      </p:sp>
+      <p:sp>
+        <p:nvSpPr>
+          <p:cNvPr id="4" name="TextBox 3"/>
+          <p:cNvSpPr txBox="1"/>
+          <p:nvPr/>
+        </p:nvSpPr>
+        <p:spPr>
+          <a:xfrm>
+            <a:off x="548640" y="731520"/>
+            <a:ext cx="11064240" cy="1005840"/>
+          </a:xfrm>
+          <a:prstGeom prst="rect">
+            <a:avLst/>
+          </a:prstGeom>
+          <a:noFill/>
+        </p:spPr>
+        <p:txBody>
+          <a:bodyPr wrap="square" anchor="t">
+            <a:spAutoFit/>
+          </a:bodyPr>
+          <a:lstStyle/>
+          <a:p>
+            <a:r>
+              <a:rPr sz="3400" b="1" i="0">
+                <a:solidFill>
+                  <a:srgbClr val="1B2025"/>
+                </a:solidFill>
+                <a:latin typeface="Avenir Next"/>
+              </a:rPr>
+              <a:t>Next hour — Lab 3</a:t>
+            </a:r>
+          </a:p>
+        </p:txBody>
+      </p:sp>
+      <p:sp>
+        <p:nvSpPr>
+          <p:cNvPr id="5" name="TextBox 4"/>
+          <p:cNvSpPr txBox="1"/>
+          <p:nvPr/>
+        </p:nvSpPr>
+        <p:spPr>
+          <a:xfrm>
+            <a:off x="548640" y="1920240"/>
+            <a:ext cx="10789920" cy="3809999"/>
+          </a:xfrm>
+          <a:prstGeom prst="rect">
+            <a:avLst/>
+          </a:prstGeom>
+          <a:noFill/>
+        </p:spPr>
+        <p:txBody>
+          <a:bodyPr wrap="square" anchor="t">
+            <a:spAutoFit/>
+          </a:bodyPr>
+          <a:lstStyle/>
+          <a:p>
+            <a:pPr>
+              <a:spcAft>
+                <a:spcPts val="1800"/>
+              </a:spcAft>
+            </a:pPr>
+            <a:r>
+              <a:rPr sz="2300" b="1" i="0">
+                <a:solidFill>
+                  <a:srgbClr val="0E7C7B"/>
+                </a:solidFill>
+                <a:latin typeface="Avenir Next"/>
+              </a:rPr>
+              <a:t>•  </a:t>
+            </a:r>
+            <a:r>
+              <a:rPr sz="2300" b="0" i="0">
+                <a:solidFill>
+                  <a:srgbClr val="1B2025"/>
+                </a:solidFill>
+                <a:latin typeface="Avenir Next"/>
+              </a:rPr>
+              <a:t>Fine-tune a pretrained transformer (DistilBERT) on a small labeled set — swap the head, freeze the body</a:t>
+            </a:r>
+          </a:p>
+          <a:p>
+            <a:pPr>
+              <a:spcAft>
+                <a:spcPts val="1800"/>
+              </a:spcAft>
+            </a:pPr>
+            <a:r>
+              <a:rPr sz="2300" b="1" i="0">
+                <a:solidFill>
+                  <a:srgbClr val="0E7C7B"/>
+                </a:solidFill>
+                <a:latin typeface="Avenir Next"/>
+              </a:rPr>
+              <a:t>•  </a:t>
+            </a:r>
+            <a:r>
+              <a:rPr sz="2300" b="0" i="0">
+                <a:solidFill>
+                  <a:srgbClr val="1B2025"/>
+                </a:solidFill>
+                <a:latin typeface="Avenir Next"/>
+              </a:rPr>
+              <a:t>Run the three-way race: full fine-tune vs. frozen-body head-only vs. from scratch</a:t>
+            </a:r>
+          </a:p>
+          <a:p>
+            <a:pPr>
+              <a:spcAft>
+                <a:spcPts val="1800"/>
+              </a:spcAft>
+            </a:pPr>
+            <a:r>
+              <a:rPr sz="2300" b="1" i="0">
+                <a:solidFill>
+                  <a:srgbClr val="0E7C7B"/>
+                </a:solidFill>
+                <a:latin typeface="Avenir Next"/>
+              </a:rPr>
+              <a:t>•  </a:t>
+            </a:r>
+            <a:r>
+              <a:rPr sz="2300" b="0" i="0">
+                <a:solidFill>
+                  <a:srgbClr val="1B2025"/>
+                </a:solidFill>
+                <a:latin typeface="Avenir Next"/>
+              </a:rPr>
+              <a:t>Watch from-scratch stall near chance while fine-tuning wins — on the same small data</a:t>
+            </a:r>
+          </a:p>
+          <a:p>
+            <a:pPr>
+              <a:spcAft>
+                <a:spcPts val="1800"/>
+              </a:spcAft>
+            </a:pPr>
+            <a:r>
+              <a:rPr sz="2300" b="1" i="0">
+                <a:solidFill>
+                  <a:srgbClr val="0E7C7B"/>
+                </a:solidFill>
+                <a:latin typeface="Avenir Next"/>
+              </a:rPr>
+              <a:t>•  </a:t>
+            </a:r>
+            <a:r>
+              <a:rPr sz="2300" b="0" i="0">
+                <a:solidFill>
+                  <a:srgbClr val="1B2025"/>
+                </a:solidFill>
+                <a:latin typeface="Avenir Next"/>
+              </a:rPr>
+              <a:t>Bonus: the same recipe on ESM-2, a protein language model, classifying peptides</a:t>
+            </a:r>
+          </a:p>
+        </p:txBody>
+      </p:sp>
+      <p:sp>
+        <p:nvSpPr>
+          <p:cNvPr id="6" name="Rectangle 5"/>
+          <p:cNvSpPr/>
+          <p:nvPr/>
+        </p:nvSpPr>
+        <p:spPr>
+          <a:xfrm>
+            <a:off x="548640" y="5843016"/>
+            <a:ext cx="10515600" cy="923544"/>
+          </a:xfrm>
+          <a:prstGeom prst="rect">
+            <a:avLst/>
+          </a:prstGeom>
+          <a:solidFill>
+            <a:srgbClr val="F1F1EC"/>
+          </a:solidFill>
+          <a:ln w="12700">
+            <a:solidFill>
+              <a:srgbClr val="E09E2F"/>
+            </a:solidFill>
+          </a:ln>
+          <a:effectLst/>
+        </p:spPr>
+        <p:style>
+          <a:lnRef idx="1">
+            <a:schemeClr val="accent1"/>
+          </a:lnRef>
+          <a:fillRef idx="3">
+            <a:schemeClr val="accent1"/>
+          </a:fillRef>
+          <a:effectRef idx="2">
+            <a:schemeClr val="accent1"/>
+          </a:effectRef>
+          <a:fontRef idx="minor">
+            <a:schemeClr val="lt1"/>
+          </a:fontRef>
+        </p:style>
+        <p:txBody>
+          <a:bodyPr rtlCol="0" anchor="ctr" wrap="square" lIns="182880" rIns="182880"/>
+          <a:lstStyle/>
+          <a:p>
+            <a:pPr algn="ctr"/>
+            <a:r>
+              <a:rPr sz="1200" b="1" i="0">
+                <a:solidFill>
+                  <a:srgbClr val="E09E2F"/>
+                </a:solidFill>
+                <a:latin typeface="Menlo"/>
+              </a:rPr>
+              <a:t>CHECKPOINT · </a:t>
+            </a:r>
+            <a:r>
+              <a:rPr sz="1700" b="0" i="0">
+                <a:solidFill>
+                  <a:srgbClr val="3D444C"/>
+                </a:solidFill>
+                <a:latin typeface="Avenir Next"/>
+              </a:rPr>
+              <a:t>2 minutes to finish Quiz 8 solo while Colab boots → we mark it together as Lab 3 opens. The first blank you'll fill is the classification HEAD you bolt onto a frozen pretrained body — exactly the move from the last slide.</a:t>
             </a:r>
           </a:p>
         </p:txBody>
@@ -8307,7 +9177,7 @@
                 </a:solidFill>
                 <a:latin typeface="Menlo"/>
               </a:rPr>
-              <a:t>NORMALIZATION · WHICH AXIS GETS AVERAGED · I-DO</a:t>
+              <a:t>POSITIONAL ENCODING · WHERE THE SIGNAL COMES FROM · I-DO</a:t>
             </a:r>
           </a:p>
         </p:txBody>
@@ -8341,14 +9211,14 @@
                 </a:solidFill>
                 <a:latin typeface="Avenir Next"/>
               </a:rPr>
-              <a:t>Batch norm vs. layer norm: what gets averaged?</a:t>
+              <a:t>The position signals are clocks at different speeds</a:t>
             </a:r>
           </a:p>
         </p:txBody>
       </p:sp>
       <p:pic>
         <p:nvPicPr>
-          <p:cNvPr id="5" name="Picture 4" descr="fig_norm_axes.png"/>
+          <p:cNvPr id="5" name="Picture 4" descr="fig_posenc_heatmap.png"/>
           <p:cNvPicPr>
             <a:picLocks noChangeAspect="1"/>
           </p:cNvPicPr>
@@ -8362,8 +9232,8 @@
         </p:blipFill>
         <p:spPr>
           <a:xfrm>
-            <a:off x="1619227" y="1828800"/>
-            <a:ext cx="8923066" cy="3358897"/>
+            <a:off x="2424107" y="1828800"/>
+            <a:ext cx="7313306" cy="3358897"/>
           </a:xfrm>
           <a:prstGeom prst="rect">
             <a:avLst/>
@@ -8389,7 +9259,7 @@
           </a:solidFill>
           <a:ln w="12700">
             <a:solidFill>
-              <a:srgbClr val="3D444C"/>
+              <a:srgbClr val="E09E2F"/>
             </a:solidFill>
           </a:ln>
           <a:effectLst/>
@@ -8414,13 +9284,22 @@
           <a:p>
             <a:pPr algn="ctr"/>
             <a:r>
+              <a:rPr sz="1200" b="1" i="0">
+                <a:solidFill>
+                  <a:srgbClr val="E09E2F"/>
+                </a:solidFill>
+                <a:latin typeface="Menlo"/>
+              </a:rPr>
+              <a:t>PAIR · </a:t>
+            </a:r>
+            <a:r>
               <a:rPr sz="1700" b="0" i="0">
                 <a:solidFill>
                   <a:srgbClr val="3D444C"/>
                 </a:solidFill>
                 <a:latin typeface="Avenir Next"/>
               </a:rPr>
-              <a:t>Rows = samples in the batch, columns = features. BATCH norm averages DOWN a feature across the batch: mean(2,4,0)=2. LAYER norm averages ACROSS one token's features: mean(2,2,6,6)=4, then subtract and divide by the spread → [2,2,6,6] − 4 = [−2,−2,2,2], ÷ std 2 = [−1,−1,1,1]. Transformers use LAYER norm: it needs no batch, so it works at batch size 1 and with variable-length sequences.</a:t>
+              <a:t>Where do those per-position signals come from? Sine/cosine waves at different speeds. LEFT: dim 0 ticks fast, dim 8 barely moves. RIGHT: stack every dimension and each POSITION gets a unique row — its fingerprint — and neighbours (boxed rows 2–3) look almost identical, so 'near' and 'far' become visible. 💬 Pair (60 sec): why do we need BOTH fast and slow clocks — what breaks with only slow ones?</a:t>
             </a:r>
           </a:p>
         </p:txBody>
@@ -8516,7 +9395,7 @@
                 </a:solidFill>
                 <a:latin typeface="Menlo"/>
               </a:rPr>
-              <a:t>NORMALIZATION · YOUR TURN (YOU-DO = Q4)</a:t>
+              <a:t>POSITIONAL ENCODING · ABSOLUTE VS. RELATIVE · I-DO</a:t>
             </a:r>
           </a:p>
         </p:txBody>
@@ -8530,7 +9409,7 @@
         <p:spPr>
           <a:xfrm>
             <a:off x="548640" y="731520"/>
-            <a:ext cx="11064240" cy="1005840"/>
+            <a:ext cx="11064240" cy="1127760"/>
           </a:xfrm>
           <a:prstGeom prst="rect">
             <a:avLst/>
@@ -8550,14 +9429,14 @@
                 </a:solidFill>
                 <a:latin typeface="Avenir Next"/>
               </a:rPr>
-              <a:t>Your matrix: which norm averages over what?</a:t>
+              <a:t>RoPE: encode the GAP between tokens, not the seat</a:t>
             </a:r>
           </a:p>
         </p:txBody>
       </p:sp>
       <p:pic>
         <p:nvPicPr>
-          <p:cNvPr id="5" name="Picture 4" descr="fig_norm_youdo.png"/>
+          <p:cNvPr id="5" name="Picture 4" descr="fig_rope.png"/>
           <p:cNvPicPr>
             <a:picLocks noChangeAspect="1"/>
           </p:cNvPicPr>
@@ -8571,8 +9450,8 @@
         </p:blipFill>
         <p:spPr>
           <a:xfrm>
-            <a:off x="1676726" y="1828800"/>
-            <a:ext cx="8808068" cy="3291840"/>
+            <a:off x="1718556" y="1828800"/>
+            <a:ext cx="8724407" cy="3358897"/>
           </a:xfrm>
           <a:prstGeom prst="rect">
             <a:avLst/>
@@ -8587,8 +9466,8 @@
         </p:nvSpPr>
         <p:spPr>
           <a:xfrm>
-            <a:off x="548640" y="5212080"/>
-            <a:ext cx="10515600" cy="1182624"/>
+            <a:off x="548640" y="5279137"/>
+            <a:ext cx="10515600" cy="1441703"/>
           </a:xfrm>
           <a:prstGeom prst="rect">
             <a:avLst/>
@@ -8629,7 +9508,7 @@
                 </a:solidFill>
                 <a:latin typeface="Menlo"/>
               </a:rPr>
-              <a:t>CHECKPOINT · </a:t>
+              <a:t>PAIR · </a:t>
             </a:r>
             <a:r>
               <a:rPr sz="1700" b="0" i="0">
@@ -8638,7 +9517,7 @@
                 </a:solidFill>
                 <a:latin typeface="Avenir Next"/>
               </a:rPr>
-              <a:t>Your turn → Quiz 8, Q4. Rows = tokens, columns = features. (a) LAYER norm averages across WHAT — and what is the mean of tok1? (b) BATCH norm averages down WHAT — and what is the mean of feature f1? (c) One reason transformers prefer layer norm. Worked answer in the notes.</a:t>
+              <a:t>Absolute encoding tags each seat ('you are at position 7'). RoPE (used by LLaMA) instead ROTATES each token's query and key by an angle set by its position, so the attention score depends only on the GAP (m−n) between two tokens — the 3θ between the two clock hands. 💬 Pair (60 sec): why does encoding the gap, not the seat, let a model handle a sequence LONGER than any it trained on?</a:t>
             </a:r>
           </a:p>
         </p:txBody>
@@ -8734,7 +9613,7 @@
                 </a:solidFill>
                 <a:latin typeface="Menlo"/>
               </a:rPr>
-              <a:t>ASSEMBLE · THE WHOLE TRANSFORMER</a:t>
+              <a:t>NORMALIZATION · WHICH AXIS GETS AVERAGED · I-DO</a:t>
             </a:r>
           </a:p>
         </p:txBody>
@@ -8748,7 +9627,7 @@
         <p:spPr>
           <a:xfrm>
             <a:off x="548640" y="731520"/>
-            <a:ext cx="11064240" cy="1005840"/>
+            <a:ext cx="11064240" cy="1127760"/>
           </a:xfrm>
           <a:prstGeom prst="rect">
             <a:avLst/>
@@ -8768,14 +9647,14 @@
                 </a:solidFill>
                 <a:latin typeface="Avenir Next"/>
               </a:rPr>
-              <a:t>Every block is one you already own</a:t>
+              <a:t>Batch norm vs. layer norm: what gets averaged?</a:t>
             </a:r>
           </a:p>
         </p:txBody>
       </p:sp>
       <p:pic>
         <p:nvPicPr>
-          <p:cNvPr id="5" name="Picture 4" descr="transformer_architecture.png"/>
+          <p:cNvPr id="5" name="Picture 4" descr="fig_norm_axes.png"/>
           <p:cNvPicPr>
             <a:picLocks noChangeAspect="1"/>
           </p:cNvPicPr>
@@ -8789,8 +9668,8 @@
         </p:blipFill>
         <p:spPr>
           <a:xfrm>
-            <a:off x="4723122" y="1828800"/>
-            <a:ext cx="2715276" cy="2855977"/>
+            <a:off x="1619227" y="1828800"/>
+            <a:ext cx="8923066" cy="3358897"/>
           </a:xfrm>
           <a:prstGeom prst="rect">
             <a:avLst/>
@@ -8799,48 +9678,13 @@
       </p:pic>
       <p:sp>
         <p:nvSpPr>
-          <p:cNvPr id="6" name="TextBox 5"/>
-          <p:cNvSpPr txBox="1"/>
-          <p:nvPr/>
-        </p:nvSpPr>
-        <p:spPr>
-          <a:xfrm>
-            <a:off x="548640" y="4739641"/>
-            <a:ext cx="11064240" cy="411480"/>
-          </a:xfrm>
-          <a:prstGeom prst="rect">
-            <a:avLst/>
-          </a:prstGeom>
-          <a:noFill/>
-        </p:spPr>
-        <p:txBody>
-          <a:bodyPr wrap="square" anchor="t">
-            <a:spAutoFit/>
-          </a:bodyPr>
-          <a:lstStyle/>
-          <a:p>
-            <a:pPr algn="ctr"/>
-            <a:r>
-              <a:rPr sz="1200" b="0" i="1">
-                <a:solidFill>
-                  <a:srgbClr val="8A9099"/>
-                </a:solidFill>
-                <a:latin typeface="Avenir Next"/>
-              </a:rPr>
-              <a:t>the full transformer · encoder (left, orange) + decoder (right, green) · diagram: dvgodoy, Wikimedia Commons, CC BY 4.0</a:t>
-            </a:r>
-          </a:p>
-        </p:txBody>
-      </p:sp>
-      <p:sp>
-        <p:nvSpPr>
-          <p:cNvPr id="7" name="Rectangle 6"/>
+          <p:cNvPr id="6" name="Rectangle 5"/>
           <p:cNvSpPr/>
           <p:nvPr/>
         </p:nvSpPr>
         <p:spPr>
           <a:xfrm>
-            <a:off x="548640" y="5242561"/>
+            <a:off x="548640" y="5279137"/>
             <a:ext cx="10515600" cy="1441703"/>
           </a:xfrm>
           <a:prstGeom prst="rect">
@@ -8882,7 +9726,7 @@
                 </a:solidFill>
                 <a:latin typeface="Avenir Next"/>
               </a:rPr>
-              <a:t>Read bottom-up. Embeddings + positional encoding (just now) → Norm (just now) → Multi-head attention (Lecture 7) → a '+' residual skip (Lecture 5) → Feed-forward network (the Lab-1 MLP) → repeat ×N. The ENCODER (left) reads the whole input; the DECODER (right) writes an output, one token at a time, and cross-attends back to the encoder.</a:t>
+              <a:t>Rows = samples in the batch, columns = features. BATCH norm averages DOWN a feature across the batch: mean(2,4,0)=2. LAYER norm averages ACROSS one token's features: mean(2,2,6,6)=4, then subtract and divide by the spread → [2,2,6,6] − 4 = [−2,−2,2,2], ÷ std 2 = [−1,−1,1,1]. Transformers use LAYER norm: it needs no batch, so it works at batch size 1 and with variable-length sequences.</a:t>
             </a:r>
           </a:p>
         </p:txBody>
@@ -8978,7 +9822,7 @@
                 </a:solidFill>
                 <a:latin typeface="Menlo"/>
               </a:rPr>
-              <a:t>ASSEMBLE · ONE BLOCK, FOUR PARTS · I-DO</a:t>
+              <a:t>NORMALIZATION · YOUR TURN · DO-IT-TOGETHER</a:t>
             </a:r>
           </a:p>
         </p:txBody>
@@ -9012,14 +9856,14 @@
                 </a:solidFill>
                 <a:latin typeface="Avenir Next"/>
               </a:rPr>
-              <a:t>One block: four parts, each with a name</a:t>
+              <a:t>Your matrix: which norm averages over what?</a:t>
             </a:r>
           </a:p>
         </p:txBody>
       </p:sp>
       <p:pic>
         <p:nvPicPr>
-          <p:cNvPr id="5" name="Picture 4" descr="fig_transformer_block.png"/>
+          <p:cNvPr id="5" name="Picture 4" descr="fig_norm_youdo.png"/>
           <p:cNvPicPr>
             <a:picLocks noChangeAspect="1"/>
           </p:cNvPicPr>
@@ -9033,8 +9877,8 @@
         </p:blipFill>
         <p:spPr>
           <a:xfrm>
-            <a:off x="3934734" y="1828800"/>
-            <a:ext cx="4292052" cy="3099816"/>
+            <a:off x="1676726" y="1828800"/>
+            <a:ext cx="8808068" cy="3291840"/>
           </a:xfrm>
           <a:prstGeom prst="rect">
             <a:avLst/>
@@ -9049,8 +9893,8 @@
         </p:nvSpPr>
         <p:spPr>
           <a:xfrm>
-            <a:off x="548640" y="5020056"/>
-            <a:ext cx="10515600" cy="1700784"/>
+            <a:off x="548640" y="5212080"/>
+            <a:ext cx="10515600" cy="1182624"/>
           </a:xfrm>
           <a:prstGeom prst="rect">
             <a:avLst/>
@@ -9060,7 +9904,7 @@
           </a:solidFill>
           <a:ln w="12700">
             <a:solidFill>
-              <a:srgbClr val="3D444C"/>
+              <a:srgbClr val="E09E2F"/>
             </a:solidFill>
           </a:ln>
           <a:effectLst/>
@@ -9085,13 +9929,22 @@
           <a:p>
             <a:pPr algn="ctr"/>
             <a:r>
+              <a:rPr sz="1200" b="1" i="0">
+                <a:solidFill>
+                  <a:srgbClr val="E09E2F"/>
+                </a:solidFill>
+                <a:latin typeface="Menlo"/>
+              </a:rPr>
+              <a:t>CHECKPOINT · </a:t>
+            </a:r>
+            <a:r>
               <a:rPr sz="1700" b="0" i="0">
                 <a:solidFill>
                   <a:srgbClr val="3D444C"/>
                 </a:solidFill>
                 <a:latin typeface="Avenir Next"/>
               </a:rPr>
-              <a:t>Simplify to one encoder block, bottom-up: ① Positional encoding (added to the input embeddings — inject order) → ② Multi-head self-attention (the Lecture-7 lookup) → ③ Add &amp; Norm (residual skip + layer norm) → ④ Feed-forward network (the MLP). The residual skip carries the input around a block and adds it back — the Lecture-5 highway. Simplified for labeling: the real diagram (prev. slide) norms before each sub-layer; here we collapse to one Add &amp; Norm per block.</a:t>
+              <a:t>Do-it-together (60 sec). Rows = tokens, columns = features. (a) LAYER norm averages across WHAT — and what is the mean of tok1? (b) BATCH norm averages down WHAT — and what is the mean of feature f1? (c) One reason transformers prefer layer norm. Answers below.</a:t>
             </a:r>
           </a:p>
         </p:txBody>
@@ -9187,7 +10040,7 @@
                 </a:solidFill>
                 <a:latin typeface="Menlo"/>
               </a:rPr>
-              <a:t>ASSEMBLE · YOUR TURN (YOU-DO = Q1)</a:t>
+              <a:t>ASSEMBLE · THE WHOLE TRANSFORMER</a:t>
             </a:r>
           </a:p>
         </p:txBody>
@@ -9221,14 +10074,14 @@
                 </a:solidFill>
                 <a:latin typeface="Avenir Next"/>
               </a:rPr>
-              <a:t>Label the four blocks</a:t>
+              <a:t>Every block is one you already own</a:t>
             </a:r>
           </a:p>
         </p:txBody>
       </p:sp>
       <p:pic>
         <p:nvPicPr>
-          <p:cNvPr id="5" name="Picture 4" descr="fig_transformer_block_youdo.png"/>
+          <p:cNvPr id="5" name="Picture 4" descr="transformer_architecture.png"/>
           <p:cNvPicPr>
             <a:picLocks noChangeAspect="1"/>
           </p:cNvPicPr>
@@ -9242,8 +10095,8 @@
         </p:blipFill>
         <p:spPr>
           <a:xfrm>
-            <a:off x="3091361" y="1828800"/>
-            <a:ext cx="5978798" cy="3877056"/>
+            <a:off x="4723122" y="1828800"/>
+            <a:ext cx="2715276" cy="2855977"/>
           </a:xfrm>
           <a:prstGeom prst="rect">
             <a:avLst/>
@@ -9252,14 +10105,49 @@
       </p:pic>
       <p:sp>
         <p:nvSpPr>
-          <p:cNvPr id="6" name="Rectangle 5"/>
+          <p:cNvPr id="6" name="TextBox 5"/>
+          <p:cNvSpPr txBox="1"/>
+          <p:nvPr/>
+        </p:nvSpPr>
+        <p:spPr>
+          <a:xfrm>
+            <a:off x="548640" y="4739641"/>
+            <a:ext cx="11064240" cy="411480"/>
+          </a:xfrm>
+          <a:prstGeom prst="rect">
+            <a:avLst/>
+          </a:prstGeom>
+          <a:noFill/>
+        </p:spPr>
+        <p:txBody>
+          <a:bodyPr wrap="square" anchor="t">
+            <a:spAutoFit/>
+          </a:bodyPr>
+          <a:lstStyle/>
+          <a:p>
+            <a:pPr algn="ctr"/>
+            <a:r>
+              <a:rPr sz="1200" b="0" i="1">
+                <a:solidFill>
+                  <a:srgbClr val="8A9099"/>
+                </a:solidFill>
+                <a:latin typeface="Avenir Next"/>
+              </a:rPr>
+              <a:t>the full transformer · encoder (left, orange) + decoder (right, green) · diagram: dvgodoy, Wikimedia Commons, CC BY 4.0</a:t>
+            </a:r>
+          </a:p>
+        </p:txBody>
+      </p:sp>
+      <p:sp>
+        <p:nvSpPr>
+          <p:cNvPr id="7" name="Rectangle 6"/>
           <p:cNvSpPr/>
           <p:nvPr/>
         </p:nvSpPr>
         <p:spPr>
           <a:xfrm>
-            <a:off x="548640" y="5797296"/>
-            <a:ext cx="10515600" cy="923544"/>
+            <a:off x="548640" y="5242561"/>
+            <a:ext cx="10515600" cy="1441703"/>
           </a:xfrm>
           <a:prstGeom prst="rect">
             <a:avLst/>
@@ -9269,7 +10157,7 @@
           </a:solidFill>
           <a:ln w="12700">
             <a:solidFill>
-              <a:srgbClr val="E09E2F"/>
+              <a:srgbClr val="3D444C"/>
             </a:solidFill>
           </a:ln>
           <a:effectLst/>
@@ -9294,22 +10182,13 @@
           <a:p>
             <a:pPr algn="ctr"/>
             <a:r>
-              <a:rPr sz="1200" b="1" i="0">
-                <a:solidFill>
-                  <a:srgbClr val="E09E2F"/>
-                </a:solidFill>
-                <a:latin typeface="Menlo"/>
-              </a:rPr>
-              <a:t>CHECKPOINT · </a:t>
-            </a:r>
-            <a:r>
               <a:rPr sz="1700" b="0" i="0">
                 <a:solidFill>
                   <a:srgbClr val="3D444C"/>
                 </a:solidFill>
                 <a:latin typeface="Avenir Next"/>
               </a:rPr>
-              <a:t>Your turn → Quiz 8, Q1. Same block, now blank. Name blocks ①–④ from the word bank: Feed-forward network · Multi-head self-attention · Add &amp; Norm (layer norm) · Positional encoding. Worked answer in the notes.</a:t>
+              <a:t>Read bottom-up. Embeddings + positional encoding (just now) → Norm (just now) → Multi-head attention (Lecture 7) → a '+' residual skip (Lecture 5) → Feed-forward network (the Lab-1 MLP) → repeat ×N. The ENCODER (left) reads the whole input; the DECODER (right) writes an output, one token at a time, and cross-attends back to the encoder.</a:t>
             </a:r>
           </a:p>
         </p:txBody>
@@ -9405,7 +10284,7 @@
                 </a:solidFill>
                 <a:latin typeface="Menlo"/>
               </a:rPr>
-              <a:t>ASSEMBLE · TWO WAYS TO WIRE IT</a:t>
+              <a:t>ASSEMBLE · ONE BLOCK, FOUR PARTS · I-DO</a:t>
             </a:r>
           </a:p>
         </p:txBody>
@@ -9439,14 +10318,14 @@
                 </a:solidFill>
                 <a:latin typeface="Avenir Next"/>
               </a:rPr>
-              <a:t>Encoder-only reads; decoder-only writes</a:t>
+              <a:t>One block: four parts, each with a name</a:t>
             </a:r>
           </a:p>
         </p:txBody>
       </p:sp>
       <p:pic>
         <p:nvPicPr>
-          <p:cNvPr id="5" name="Picture 4" descr="fig_bert_vs_gpt.png"/>
+          <p:cNvPr id="5" name="Picture 4" descr="fig_transformer_block.png"/>
           <p:cNvPicPr>
             <a:picLocks noChangeAspect="1"/>
           </p:cNvPicPr>
@@ -9460,8 +10339,8 @@
         </p:blipFill>
         <p:spPr>
           <a:xfrm>
-            <a:off x="1821289" y="1828800"/>
-            <a:ext cx="8518941" cy="3358897"/>
+            <a:off x="3934734" y="1828800"/>
+            <a:ext cx="4292052" cy="3099816"/>
           </a:xfrm>
           <a:prstGeom prst="rect">
             <a:avLst/>
@@ -9476,8 +10355,8 @@
         </p:nvSpPr>
         <p:spPr>
           <a:xfrm>
-            <a:off x="548640" y="5279137"/>
-            <a:ext cx="10515600" cy="1441703"/>
+            <a:off x="548640" y="5020056"/>
+            <a:ext cx="10515600" cy="1700784"/>
           </a:xfrm>
           <a:prstGeom prst="rect">
             <a:avLst/>
@@ -9487,7 +10366,7 @@
           </a:solidFill>
           <a:ln w="12700">
             <a:solidFill>
-              <a:srgbClr val="E09E2F"/>
+              <a:srgbClr val="3D444C"/>
             </a:solidFill>
           </a:ln>
           <a:effectLst/>
@@ -9512,22 +10391,13 @@
           <a:p>
             <a:pPr algn="ctr"/>
             <a:r>
-              <a:rPr sz="1200" b="1" i="0">
-                <a:solidFill>
-                  <a:srgbClr val="E09E2F"/>
-                </a:solidFill>
-                <a:latin typeface="Menlo"/>
-              </a:rPr>
-              <a:t>PAIR · </a:t>
-            </a:r>
-            <a:r>
               <a:rPr sz="1700" b="0" i="0">
                 <a:solidFill>
                   <a:srgbClr val="3D444C"/>
                 </a:solidFill>
                 <a:latin typeface="Avenir Next"/>
               </a:rPr>
-              <a:t>Encoder-only (BERT): read the WHOLE sequence both directions → one label/embedding (call a spectrum resistant/susceptible, or embed a peptide). Decoder-only (GPT): generate the next token left to right → write a peptide residue by residue. 💬 Your turn (30 sec): a model that writes a peptide one residue at a time — encoder-only or decoder-only, and why? Worked answer in the notes.</a:t>
+              <a:t>Simplify to one encoder block, bottom-up: ① Positional encoding (added to the input embeddings — inject order) → ② Multi-head self-attention (the Lecture-7 lookup) → ③ Add &amp; Norm (residual skip + layer norm) → ④ Feed-forward network (the MLP). The residual skip carries the input around a block and adds it back — the Lecture-5 highway. Note: the real diagram (prev. slide) norms before each sub-layer; here we collapse to one Add &amp; Norm per block for a clean picture.</a:t>
             </a:r>
           </a:p>
         </p:txBody>

</xml_diff>